<commit_message>
Publish verified executive presentation with corrected claims and HUD screenshots
</commit_message>
<xml_diff>
--- a/docs/presentation/protokol-presentation.pptx
+++ b/docs/presentation/protokol-presentation.pptx
@@ -581,7 +581,7 @@
           <a:lstStyle/>
           <a:p>
             <a:r>
-              <a:t>Слайд 10: Финальное резюме для принятия решения. Продукт готов к пилотному турнирному запуску. Сформулированы понятные шаги дальнейшего технологического лидерства.</a:t>
+              <a:t>Слайд 10: Финальное резюме. Зафиксированы подтвержденные возможности версии 0.1.0, границы текущей верификации и практический план дальнейшего развития продукта.</a:t>
             </a:r>
           </a:p>
         </p:txBody>
@@ -651,7 +651,7 @@
           <a:lstStyle/>
           <a:p>
             <a:r>
-              <a:t>Слайд 2: Инженерное и финансовое обоснование. LHM и EideticHM создают риски сбоев во время стрима из-за утечек памяти. PROTOKOL снижает нагрузку на систему вещания на 80-85% и запускается из одного автономного файла.</a:t>
+              <a:t>Слайд 2: Инженерное и функциональное обоснование. В отличие от legacy-решений, PROTOKOL объединяет прием GSI, SQLite-хранилище и управление вещанием в едином нативном приложении с автоматической настройкой конфигов CS2.</a:t>
             </a:r>
           </a:p>
         </p:txBody>
@@ -721,7 +721,7 @@
           <a:lstStyle/>
           <a:p>
             <a:r>
-              <a:t>Слайд 3: Стиль Fennec Cyber. Особенность: агрессивная, молодежная геометрия. Скриншот показывает тестовый видеопоток (SMPTE-таймкод) в окне камеры. В реальном матче при наведении спектатора на игрока здесь мгновенно активируется его веб-камера.</a:t>
+              <a:t>Слайд 3: Стиль Fennec Cyber. Особенность: энергичная киберспортивная геометрия. Скриншот показывает тестовый видеопоток (SMPTE-таймкод) в окне камеры. При переключении спектатора на игрока в оверлее активируется привязанная веб-камера.</a:t>
             </a:r>
           </a:p>
         </p:txBody>
@@ -1071,7 +1071,7 @@
           <a:lstStyle/>
           <a:p>
             <a:r>
-              <a:t>Слайд 8: Архитектурная надежность. Разделение ответственности: быстрый сетевой GSI-парсинг на Rust, трансляция по WebSocket на 60 FPS, изолированная запись в SQLite WAL.</a:t>
+              <a:t>Слайд 8: Архитектурная надежность. Разделение ответственности: сетевой GSI-приемник на Rust Axum, раздача событий по WebSocket в оверлеи и асинхронное сохранение сессий в SQLite WAL.</a:t>
             </a:r>
           </a:p>
         </p:txBody>
@@ -1141,7 +1141,7 @@
           <a:lstStyle/>
           <a:p>
             <a:r>
-              <a:t>Слайд 9: Прозрачный статус контроля качества. Инженерная честность повышает доверие руководства: мы четко фиксируем, что доказано автотестами, а что требует финальной приемочной проверки на Windows-машине режиссера.</a:t>
+              <a:t>Слайд 9: Прозрачный статус контроля качества. Инженерная честность: четко фиксируем, что доказано автотестами (36 тестов библиотеки, 5 тестов хранилища, 33 backend E2E), а что требует приемки на физической Windows-машине и в боевой CS2 турнирной сессии.</a:t>
             </a:r>
           </a:p>
         </p:txBody>
@@ -4498,7 +4498,7 @@
               </a:defRPr>
             </a:pPr>
             <a:r>
-              <a:t>ПАМЯТЬ</a:t>
+              <a:t>БАЗА ДАННЫХ</a:t>
             </a:r>
           </a:p>
           <a:p>
@@ -4510,7 +4510,7 @@
               </a:defRPr>
             </a:pPr>
             <a:r>
-              <a:t>30–60 MB RAM</a:t>
+              <a:t>SQLite WAL (локально)</a:t>
             </a:r>
           </a:p>
         </p:txBody>
@@ -4590,7 +4590,7 @@
               </a:defRPr>
             </a:pPr>
             <a:r>
-              <a:t>ЧАСТОТА ОБНОВЛЕНИЯ</a:t>
+              <a:t>ТЕЛЕМЕТРИЯ CS2</a:t>
             </a:r>
           </a:p>
           <a:p>
@@ -4602,7 +4602,7 @@
               </a:defRPr>
             </a:pPr>
             <a:r>
-              <a:t>60 Hz Realtime WS</a:t>
+              <a:t>Realtime WebSocket</a:t>
             </a:r>
           </a:p>
         </p:txBody>
@@ -4682,7 +4682,7 @@
               </a:defRPr>
             </a:pPr>
             <a:r>
-              <a:t>ОБСЛУЖИВАНИЕ</a:t>
+              <a:t>ФОРМ-ФАКТОР</a:t>
             </a:r>
           </a:p>
           <a:p>
@@ -4694,7 +4694,7 @@
               </a:defRPr>
             </a:pPr>
             <a:r>
-              <a:t>Zero-Dependency .exe</a:t>
+              <a:t>Tauri Desktop App</a:t>
             </a:r>
           </a:p>
         </p:txBody>
@@ -4774,7 +4774,7 @@
               </a:defRPr>
             </a:pPr>
             <a:r>
-              <a:t>PROTOKOL HUD Manager  •  Комплекс CS2 турнирных трансляций  •  Версия v2.0.0</a:t>
+              <a:t>PROTOKOL HUD Manager  •  Комплекс CS2 турнирных трансляций  •  Версия v0.1.0</a:t>
             </a:r>
           </a:p>
         </p:txBody>
@@ -5032,7 +5032,7 @@
               </a:defRPr>
             </a:pPr>
             <a:r>
-              <a:t>★ Снижение риска срыва эфира: </a:t>
+              <a:t>★ Снижение риска сбоев эфира: </a:t>
             </a:r>
           </a:p>
           <a:p>
@@ -5044,7 +5044,7 @@
               </a:defRPr>
             </a:pPr>
             <a:r>
-              <a:t>Минимальный след по оперативной памяти (30–60 МБ) и отсутствие тяжелого фонового рантайма гарантируют стабильность на 5+ часовых марафонах.</a:t>
+              <a:t>Отказ от внешнего рантайма Node.js и тяжелых промежуточных сервисов в пользу скомпилированного нативного бэкенда.</a:t>
             </a:r>
           </a:p>
           <a:p>
@@ -5196,7 +5196,7 @@
               </a:defRPr>
             </a:pPr>
             <a:r>
-              <a:t>ПЛАН РАЗВИТИЯ СИСТЕМЫ (ROADMAP v2.1+)</a:t>
+              <a:t>ПЛАН РАЗВИТИЯ СИСТЕМЫ (ROADMAP v0.2+)</a:t>
             </a:r>
           </a:p>
           <a:p>
@@ -5372,7 +5372,7 @@
               </a:defRPr>
             </a:pPr>
             <a:r>
-              <a:t>PROTOKOL HUD Manager  •  Комплекс CS2 турнирных трансляций  •  Версия v2.0.0</a:t>
+              <a:t>PROTOKOL HUD Manager  •  Комплекс CS2 турнирных трансляций  •  Версия v0.1.0</a:t>
             </a:r>
           </a:p>
         </p:txBody>
@@ -5769,7 +5769,7 @@
                         </a:defRPr>
                       </a:pPr>
                       <a:r>
-                        <a:t>Потребление RAM</a:t>
+                        <a:t>Конфигурация GSI</a:t>
                       </a:r>
                     </a:p>
                   </a:txBody>
@@ -5792,7 +5792,7 @@
                         </a:defRPr>
                       </a:pPr>
                       <a:r>
-                        <a:t>300–500 MB (утечки)</a:t>
+                        <a:t>Ручная правка cfg</a:t>
                       </a:r>
                     </a:p>
                   </a:txBody>
@@ -5815,7 +5815,7 @@
                         </a:defRPr>
                       </a:pPr>
                       <a:r>
-                        <a:t>150–250 MB</a:t>
+                        <a:t>Ручное копирование</a:t>
                       </a:r>
                     </a:p>
                   </a:txBody>
@@ -5838,7 +5838,7 @@
                         </a:defRPr>
                       </a:pPr>
                       <a:r>
-                        <a:t>30–60 MB (минимально)</a:t>
+                        <a:t>Автогенерация из GUI</a:t>
                       </a:r>
                     </a:p>
                   </a:txBody>
@@ -6253,7 +6253,7 @@
               </a:defRPr>
             </a:pPr>
             <a:r>
-              <a:t>Безотказность на длинных матчах</a:t>
+              <a:t>Скомпилированное нативное ядро</a:t>
             </a:r>
           </a:p>
           <a:p>
@@ -6265,7 +6265,7 @@
               </a:defRPr>
             </a:pPr>
             <a:r>
-              <a:t>Нативное ядро Rust исключает утечки памяти и зависания процессов Chromium на тяжелых BO3/BO5 турнирных сериях.</a:t>
+              <a:t>Бэкенд на Rust с Axum и асинхронным рантаймом Tokio вместо интерпретируемых серверных скриптов.</a:t>
             </a:r>
           </a:p>
         </p:txBody>
@@ -6388,7 +6388,7 @@
               </a:defRPr>
             </a:pPr>
             <a:r>
-              <a:t>Автономность без внешнего рантайма</a:t>
+              <a:t>Единый настольный комплекс</a:t>
             </a:r>
           </a:p>
           <a:p>
@@ -6400,7 +6400,7 @@
               </a:defRPr>
             </a:pPr>
             <a:r>
-              <a:t>Полноценный независимый бинарник без необходимости устанавливать Node.js, npm-пакеты или веб-серверы на вещательном ПК.</a:t>
+              <a:t>Tauri v2 объединяет интерфейс оператора, прием GSI, хранилище SQLite и отдачу оверлеев в единое приложение.</a:t>
             </a:r>
           </a:p>
         </p:txBody>
@@ -6535,7 +6535,7 @@
               </a:defRPr>
             </a:pPr>
             <a:r>
-              <a:t>Централизованный интерфейс оператора для мгновенного управления составами, картами, спонсорами и стилями без перезапуска игры.</a:t>
+              <a:t>Централизованный интерфейс оператора для управления составами, картами, спонсорами и стилями без перезапуска игры.</a:t>
             </a:r>
           </a:p>
         </p:txBody>
@@ -6615,7 +6615,7 @@
               </a:defRPr>
             </a:pPr>
             <a:r>
-              <a:t>PROTOKOL HUD Manager  •  Комплекс CS2 турнирных трансляций  •  Версия v2.0.0</a:t>
+              <a:t>PROTOKOL HUD Manager  •  Комплекс CS2 турнирных трансляций  •  Версия v0.1.0</a:t>
             </a:r>
           </a:p>
         </p:txBody>
@@ -7173,7 +7173,7 @@
               </a:defRPr>
             </a:pPr>
             <a:r>
-              <a:t>PROTOKOL HUD Manager  •  Комплекс CS2 турнирных трансляций  •  Версия v2.0.0</a:t>
+              <a:t>PROTOKOL HUD Manager  •  Комплекс CS2 турнирных трансляций  •  Версия v0.1.0</a:t>
             </a:r>
           </a:p>
         </p:txBody>
@@ -7622,7 +7622,7 @@
               </a:defRPr>
             </a:pPr>
             <a:r>
-              <a:t>Крупные, мгновенно считываемые цифры здоровья, патронов и статус саппорт-утилит команд.</a:t>
+              <a:t>Крупные, четко считываемые цифры здоровья, патронов и статус саппорт-утилит команд.</a:t>
             </a:r>
           </a:p>
           <a:p>
@@ -7731,7 +7731,7 @@
               </a:defRPr>
             </a:pPr>
             <a:r>
-              <a:t>PROTOKOL HUD Manager  •  Комплекс CS2 турнирных трансляций  •  Версия v2.0.0</a:t>
+              <a:t>PROTOKOL HUD Manager  •  Комплекс CS2 турнирных трансляций  •  Версия v0.1.0</a:t>
             </a:r>
           </a:p>
         </p:txBody>
@@ -8209,7 +8209,7 @@
               </a:defRPr>
             </a:pPr>
             <a:r>
-              <a:t>Гранд-финалы, арена-стадии, международные чемпионаты и премиальные шоу-матчи.</a:t>
+              <a:t>Финальные стадии, арена-трансляции, турнирные серии и шоу-матчи.</a:t>
             </a:r>
           </a:p>
         </p:txBody>
@@ -8289,7 +8289,7 @@
               </a:defRPr>
             </a:pPr>
             <a:r>
-              <a:t>PROTOKOL HUD Manager  •  Комплекс CS2 турнирных трансляций  •  Версия v2.0.0</a:t>
+              <a:t>PROTOKOL HUD Manager  •  Комплекс CS2 турнирных трансляций  •  Версия v0.1.0</a:t>
             </a:r>
           </a:p>
         </p:txBody>
@@ -8738,7 +8738,7 @@
               </a:defRPr>
             </a:pPr>
             <a:r>
-              <a:t>Оператор может мгновенно проверить статус потока каждого игрока в один клик прямо из таблицы управления камерами.</a:t>
+              <a:t>Оператор может проверить статус потока каждого игрока в один клик прямо из таблицы управления камерами.</a:t>
             </a:r>
           </a:p>
         </p:txBody>
@@ -8818,7 +8818,7 @@
               </a:defRPr>
             </a:pPr>
             <a:r>
-              <a:t>PROTOKOL HUD Manager  •  Комплекс CS2 турнирных трансляций  •  Версия v2.0.0</a:t>
+              <a:t>PROTOKOL HUD Manager  •  Комплекс CS2 турнирных трансляций  •  Версия v0.1.0</a:t>
             </a:r>
           </a:p>
         </p:txBody>
@@ -9347,7 +9347,7 @@
               </a:defRPr>
             </a:pPr>
             <a:r>
-              <a:t>PROTOKOL HUD Manager  •  Комплекс CS2 турнирных трансляций  •  Версия v2.0.0</a:t>
+              <a:t>PROTOKOL HUD Manager  •  Комплекс CS2 турнирных трансляций  •  Версия v0.1.0</a:t>
             </a:r>
           </a:p>
         </p:txBody>
@@ -9443,7 +9443,7 @@
               </a:defRPr>
             </a:pPr>
             <a:r>
-              <a:t>ИНЖЕНЕРИЯ И НАДЕЖНОСТЬ  •  HIGH PERFORMANCE</a:t>
+              <a:t>ИНЖЕНЕРИЯ И АРХИТЕКТУРА</a:t>
             </a:r>
           </a:p>
         </p:txBody>
@@ -9513,7 +9513,7 @@
               </a:defRPr>
             </a:pPr>
             <a:r>
-              <a:t>Субмиллисекундная обработка пакетов Valve CS2 GSI и векторный радар на 18 соревновательных карт</a:t>
+              <a:t>Обработка пакетов Valve CS2 GSI и векторный радар на 18 соревновательных карт</a:t>
             </a:r>
           </a:p>
         </p:txBody>
@@ -9617,7 +9617,7 @@
               </a:defRPr>
             </a:pPr>
             <a:r>
-              <a:t>• Прием JSON-пейлоадов от движка CS2 (10–60 раз в секунду).</a:t>
+              <a:t>• Прием JSON-пейлоадов от движка CS2 по спецификации GSI.</a:t>
             </a:r>
           </a:p>
           <a:p>
@@ -9629,7 +9629,7 @@
               </a:defRPr>
             </a:pPr>
             <a:r>
-              <a:t>• Совместимый порт-мост :31982 с токеном авторизации.</a:t>
+              <a:t>• Совместимый порт-мост :31982 с проверкой токена авторизации.</a:t>
             </a:r>
           </a:p>
           <a:p>
@@ -9653,7 +9653,7 @@
               </a:defRPr>
             </a:pPr>
             <a:r>
-              <a:t>• Трекинг фрагов раунда (round_kills) для мгновенной индикации на карточке.</a:t>
+              <a:t>• Трекинг фрагов раунда (round_kills) для индикации на карточке.</a:t>
             </a:r>
           </a:p>
         </p:txBody>
@@ -9757,7 +9757,7 @@
               </a:defRPr>
             </a:pPr>
             <a:r>
-              <a:t>• Атомарный MatchSnap обновляется в памяти без блокировок потока.</a:t>
+              <a:t>• Атомарное обновление структуры MatchSnap в асинхронном рантайме.</a:t>
             </a:r>
           </a:p>
           <a:p>
@@ -9781,7 +9781,7 @@
               </a:defRPr>
             </a:pPr>
             <a:r>
-              <a:t>• Полная изоляция процессов: сбой базы не влияет на realtime-трансляцию.</a:t>
+              <a:t>• Асинхронные задачи Tokio для записи истории без блокировки сетевого цикла.</a:t>
             </a:r>
           </a:p>
           <a:p>
@@ -9793,7 +9793,7 @@
               </a:defRPr>
             </a:pPr>
             <a:r>
-              <a:t>• Потребление RAM всего 30–60 MB даже при многочасовом непрерывном вещании.</a:t>
+              <a:t>• Компактный нативный бинарник без тяжелого виртуального окружения.</a:t>
             </a:r>
           </a:p>
         </p:txBody>
@@ -9885,7 +9885,7 @@
               </a:defRPr>
             </a:pPr>
             <a:r>
-              <a:t>• WebSocket Broadcast 60 Hz</a:t>
+              <a:t>• WebSocket Broadcast (Realtime)</a:t>
             </a:r>
           </a:p>
           <a:p>
@@ -9897,7 +9897,7 @@
               </a:defRPr>
             </a:pPr>
             <a:r>
-              <a:t>• Мгновенная доставка кадров в оверлеи без задержек и артефактов.</a:t>
+              <a:t>• Событийная доставка обновлений состояния матча в оверлеи OBS Studio.</a:t>
             </a:r>
           </a:p>
           <a:p>
@@ -9921,7 +9921,7 @@
               </a:defRPr>
             </a:pPr>
             <a:r>
-              <a:t>• Удален черный фон: чистые неоновые контуры с мягким glow.</a:t>
+              <a:t>• Прозрачный альфа-канал без черного фона с контурным свечением.</a:t>
             </a:r>
           </a:p>
           <a:p>
@@ -10013,7 +10013,7 @@
               </a:defRPr>
             </a:pPr>
             <a:r>
-              <a:t>PROTOKOL HUD Manager  •  Комплекс CS2 турнирных трансляций  •  Версия v2.0.0</a:t>
+              <a:t>PROTOKOL HUD Manager  •  Комплекс CS2 турнирных трансляций  •  Версия v0.1.0</a:t>
             </a:r>
           </a:p>
         </p:txBody>
@@ -10355,7 +10355,7 @@
               </a:defRPr>
             </a:pPr>
             <a:r>
-              <a:t>33 E2E теста бэкенда пройдены успешно; 31 модульный тест Rust и 5 интеграционных тестов SQLite выполнены без ошибок.</a:t>
+              <a:t>33 E2E теста бэкенда пройдены успешно; 36 модульных тестов библиотеки и 5 интеграционных тестов camera_storage выполнены без ошибок.</a:t>
             </a:r>
           </a:p>
           <a:p>
@@ -10483,7 +10483,7 @@
               </a:defRPr>
             </a:pPr>
             <a:r>
-              <a:t>Сборка protokol-hud-manager.exe (18.8 МБ) и NSIS установщика (114 МБ) успешно скомпилирована. Заголовки PE и контрольные суммы SHA-256 проверены. Финальное тестирование в рантайме требует физического запуска на Windows с системным WebView2.</a:t>
+              <a:t>Сборка protokol-hud-manager.exe (18.8 МБ) и NSIS установщика (114 МБ) успешно скомпилирована. Заголовки PE и контрольные суммы SHA-256 проверены. Финальное подтверждение нативного Windows GUI остается открытым (signoff pending) до ручной приемки в среде с системным WebView2.</a:t>
             </a:r>
           </a:p>
           <a:p>
@@ -10507,7 +10507,7 @@
               </a:defRPr>
             </a:pPr>
             <a:r>
-              <a:t>Текущие скриншоты оверлеев используют сгенерированные тестовые таблицы (SMPTE таймкод), а не живые потоки VDO.Ninja реального турнира.</a:t>
+              <a:t>Текущие скриншоты оверлеев используют сгенерированные тестовые таблицы (SMPTE таймкод), а не живые потоки VDO.Ninja реального турнира. Сквозная турнирная сессия CS2 в боевых условиях пока не подтверждена.</a:t>
             </a:r>
           </a:p>
           <a:p>
@@ -10519,7 +10519,7 @@
               </a:defRPr>
             </a:pPr>
             <a:r>
-              <a:t>• Отсутствие фиктивных заявлений: </a:t>
+              <a:t>• Отсутствие невалидированных бенчмарков: </a:t>
             </a:r>
           </a:p>
           <a:p>
@@ -10531,7 +10531,7 @@
               </a:defRPr>
             </a:pPr>
             <a:r>
-              <a:t>Система честно позиционируется как готовый к предтурнирным испытаниям продукт. В релизных материалах исключены нереалистичные бенчмарки и выдуманные статусы «Major certified».</a:t>
+              <a:t>В релизных материалах исключены неподтвержденные бенчмарки RAM и задержек, а также громкие маркетинговые статусы. Текущая версия приложения — 0.1.0.</a:t>
             </a:r>
           </a:p>
         </p:txBody>
@@ -10611,7 +10611,7 @@
               </a:defRPr>
             </a:pPr>
             <a:r>
-              <a:t>PROTOKOL HUD Manager  •  Комплекс CS2 турнирных трансляций  •  Версия v2.0.0</a:t>
+              <a:t>PROTOKOL HUD Manager  •  Комплекс CS2 турнирных трансляций  •  Версия v0.1.0</a:t>
             </a:r>
           </a:p>
         </p:txBody>

</xml_diff>

<commit_message>
Presentation 13 slides: agent-fallback HUD screenshots, install/GSI/OBS/cameras onboarding, honest QA status
</commit_message>
<xml_diff>
--- a/docs/presentation/protokol-presentation.pptx
+++ b/docs/presentation/protokol-presentation.pptx
@@ -15,6 +15,9 @@
     <p:sldId id="263" r:id="rId15"/>
     <p:sldId id="264" r:id="rId16"/>
     <p:sldId id="265" r:id="rId17"/>
+    <p:sldId id="266" r:id="rId18"/>
+    <p:sldId id="267" r:id="rId19"/>
+    <p:sldId id="268" r:id="rId20"/>
   </p:sldIdLst>
   <p:sldSz cx="12191695" cy="6858000" type="screen4x3"/>
   <p:notesSz cx="6858000" cy="9144000"/>
@@ -606,6 +609,216 @@
 </p:notes>
 </file>
 
+<file path=ppt/notesSlides/notesSlide11.xml><?xml version="1.0" encoding="utf-8"?>
+<p:notes xmlns:a="http://schemas.openxmlformats.org/drawingml/2006/main" xmlns:p="http://schemas.openxmlformats.org/presentationml/2006/main" xmlns:r="http://schemas.openxmlformats.org/officeDocument/2006/relationships">
+  <p:cSld>
+    <p:spTree>
+      <p:nvGrpSpPr>
+        <p:cNvPr id="1" name=""/>
+        <p:cNvGrpSpPr/>
+        <p:nvPr/>
+      </p:nvGrpSpPr>
+      <p:grpSpPr>
+        <a:xfrm>
+          <a:off x="0" y="0"/>
+          <a:ext cx="0" cy="0"/>
+          <a:chOff x="0" y="0"/>
+          <a:chExt cx="0" cy="0"/>
+        </a:xfrm>
+      </p:grpSpPr>
+      <p:sp>
+        <p:nvSpPr>
+          <p:cNvPr id="2" name="Slide Image Placeholder 1"/>
+          <p:cNvSpPr>
+            <a:spLocks noGrp="1"/>
+          </p:cNvSpPr>
+          <p:nvPr>
+            <p:ph type="sldImg" idx="2"/>
+          </p:nvPr>
+        </p:nvSpPr>
+        <p:spPr/>
+      </p:sp>
+      <p:sp>
+        <p:nvSpPr>
+          <p:cNvPr id="3" name="Notes Placeholder 2"/>
+          <p:cNvSpPr>
+            <a:spLocks noGrp="1"/>
+          </p:cNvSpPr>
+          <p:nvPr>
+            <p:ph type="body" idx="3" sz="quarter"/>
+          </p:nvPr>
+        </p:nvSpPr>
+        <p:spPr/>
+        <p:txBody>
+          <a:bodyPr/>
+          <a:lstStyle/>
+          <a:p>
+            <a:r>
+              <a:t>Слайд 11: Практическое развёртывание и настройка CS2 GSI. Акцент на критическом требовании Valve: полные данные по всем 10 игрокам и радару передаются исключительно на клиент наблюдателя (GOTV / Spectator), а не на обычный клиент игрока (POV). Настройка конфига выполняется в один клик из интерфейса Настроек менеджера.</a:t>
+            </a:r>
+          </a:p>
+        </p:txBody>
+      </p:sp>
+      <p:sp>
+        <p:nvSpPr>
+          <p:cNvPr id="4" name="Slide Number Placeholder 3"/>
+          <p:cNvSpPr>
+            <a:spLocks noGrp="1"/>
+          </p:cNvSpPr>
+          <p:nvPr>
+            <p:ph type="sldNum" idx="5" sz="quarter"/>
+          </p:nvPr>
+        </p:nvSpPr>
+        <p:spPr/>
+      </p:sp>
+    </p:spTree>
+  </p:cSld>
+  <p:clrMapOvr>
+    <a:masterClrMapping/>
+  </p:clrMapOvr>
+</p:notes>
+</file>
+
+<file path=ppt/notesSlides/notesSlide12.xml><?xml version="1.0" encoding="utf-8"?>
+<p:notes xmlns:a="http://schemas.openxmlformats.org/drawingml/2006/main" xmlns:p="http://schemas.openxmlformats.org/presentationml/2006/main" xmlns:r="http://schemas.openxmlformats.org/officeDocument/2006/relationships">
+  <p:cSld>
+    <p:spTree>
+      <p:nvGrpSpPr>
+        <p:cNvPr id="1" name=""/>
+        <p:cNvGrpSpPr/>
+        <p:nvPr/>
+      </p:nvGrpSpPr>
+      <p:grpSpPr>
+        <a:xfrm>
+          <a:off x="0" y="0"/>
+          <a:ext cx="0" cy="0"/>
+          <a:chOff x="0" y="0"/>
+          <a:chExt cx="0" cy="0"/>
+        </a:xfrm>
+      </p:grpSpPr>
+      <p:sp>
+        <p:nvSpPr>
+          <p:cNvPr id="2" name="Slide Image Placeholder 1"/>
+          <p:cNvSpPr>
+            <a:spLocks noGrp="1"/>
+          </p:cNvSpPr>
+          <p:nvPr>
+            <p:ph type="sldImg" idx="2"/>
+          </p:nvPr>
+        </p:nvSpPr>
+        <p:spPr/>
+      </p:sp>
+      <p:sp>
+        <p:nvSpPr>
+          <p:cNvPr id="3" name="Notes Placeholder 2"/>
+          <p:cNvSpPr>
+            <a:spLocks noGrp="1"/>
+          </p:cNvSpPr>
+          <p:nvPr>
+            <p:ph type="body" idx="3" sz="quarter"/>
+          </p:nvPr>
+        </p:nvSpPr>
+        <p:spPr/>
+        <p:txBody>
+          <a:bodyPr/>
+          <a:lstStyle/>
+          <a:p>
+            <a:r>
+              <a:t>Слайд 12: Настройка эфирного софта и оверлеев. Разбор критических настроек OBS Browser Source — предотвращение разрыва WebSocket-канала при переключении сцен. Демонстрация безопасного импорта паков через ZIP-архивы и раздачи оверлеев из AppData.</a:t>
+            </a:r>
+          </a:p>
+        </p:txBody>
+      </p:sp>
+      <p:sp>
+        <p:nvSpPr>
+          <p:cNvPr id="4" name="Slide Number Placeholder 3"/>
+          <p:cNvSpPr>
+            <a:spLocks noGrp="1"/>
+          </p:cNvSpPr>
+          <p:nvPr>
+            <p:ph type="sldNum" idx="5" sz="quarter"/>
+          </p:nvPr>
+        </p:nvSpPr>
+        <p:spPr/>
+      </p:sp>
+    </p:spTree>
+  </p:cSld>
+  <p:clrMapOvr>
+    <a:masterClrMapping/>
+  </p:clrMapOvr>
+</p:notes>
+</file>
+
+<file path=ppt/notesSlides/notesSlide13.xml><?xml version="1.0" encoding="utf-8"?>
+<p:notes xmlns:a="http://schemas.openxmlformats.org/drawingml/2006/main" xmlns:p="http://schemas.openxmlformats.org/presentationml/2006/main" xmlns:r="http://schemas.openxmlformats.org/officeDocument/2006/relationships">
+  <p:cSld>
+    <p:spTree>
+      <p:nvGrpSpPr>
+        <p:cNvPr id="1" name=""/>
+        <p:cNvGrpSpPr/>
+        <p:nvPr/>
+      </p:nvGrpSpPr>
+      <p:grpSpPr>
+        <a:xfrm>
+          <a:off x="0" y="0"/>
+          <a:ext cx="0" cy="0"/>
+          <a:chOff x="0" y="0"/>
+          <a:chExt cx="0" cy="0"/>
+        </a:xfrm>
+      </p:grpSpPr>
+      <p:sp>
+        <p:nvSpPr>
+          <p:cNvPr id="2" name="Slide Image Placeholder 1"/>
+          <p:cNvSpPr>
+            <a:spLocks noGrp="1"/>
+          </p:cNvSpPr>
+          <p:nvPr>
+            <p:ph type="sldImg" idx="2"/>
+          </p:nvPr>
+        </p:nvSpPr>
+        <p:spPr/>
+      </p:sp>
+      <p:sp>
+        <p:nvSpPr>
+          <p:cNvPr id="3" name="Notes Placeholder 2"/>
+          <p:cNvSpPr>
+            <a:spLocks noGrp="1"/>
+          </p:cNvSpPr>
+          <p:nvPr>
+            <p:ph type="body" idx="3" sz="quarter"/>
+          </p:nvPr>
+        </p:nvSpPr>
+        <p:spPr/>
+        <p:txBody>
+          <a:bodyPr/>
+          <a:lstStyle/>
+          <a:p>
+            <a:r>
+              <a:t>Слайд 13: Работа с веб-камерами и регламент оператора. Гарантия стабильности: система кэширования DOM предотвращает мерцание видеопотоков, а при отсутствии веб-камеры включается статический аватар агента. Чек-лист и типовые сценарии устранения неполадок обеспечивают готовность технической бригады к любым инцидентам.</a:t>
+            </a:r>
+          </a:p>
+        </p:txBody>
+      </p:sp>
+      <p:sp>
+        <p:nvSpPr>
+          <p:cNvPr id="4" name="Slide Number Placeholder 3"/>
+          <p:cNvSpPr>
+            <a:spLocks noGrp="1"/>
+          </p:cNvSpPr>
+          <p:nvPr>
+            <p:ph type="sldNum" idx="5" sz="quarter"/>
+          </p:nvPr>
+        </p:nvSpPr>
+        <p:spPr/>
+      </p:sp>
+    </p:spTree>
+  </p:cSld>
+  <p:clrMapOvr>
+    <a:masterClrMapping/>
+  </p:clrMapOvr>
+</p:notes>
+</file>
+
 <file path=ppt/notesSlides/notesSlide2.xml><?xml version="1.0" encoding="utf-8"?>
 <p:notes xmlns:a="http://schemas.openxmlformats.org/drawingml/2006/main" xmlns:p="http://schemas.openxmlformats.org/presentationml/2006/main" xmlns:r="http://schemas.openxmlformats.org/officeDocument/2006/relationships">
   <p:cSld>
@@ -721,7 +934,7 @@
           <a:lstStyle/>
           <a:p>
             <a:r>
-              <a:t>Слайд 3: Стиль Fennec Cyber. Особенность: энергичная киберспортивная геометрия. Скриншот показывает тестовый видеопоток (SMPTE-таймкод) в окне камеры. При переключении спектатора на игрока в оверлее активируется привязанная веб-камера.</a:t>
+              <a:t>Слайд 3: Стиль Fennec Cyber. Особенность: энергичная киберспортивная геометрия. Скриншот демонстрирует прозрачный радар и статический 2D-фолбэк агента спецназа (SAS/CT) при отсутствии активной веб-камеры (не является видеопотоком камеры, без имитации игрового фона). При подключении камеры окно бесшовно занимает живой видеопоток.</a:t>
             </a:r>
           </a:p>
         </p:txBody>
@@ -791,7 +1004,7 @@
           <a:lstStyle/>
           <a:p>
             <a:r>
-              <a:t>Слайд 4: Fennec Broadcast — эталонный пак по чистоте верстки. В визуальных тестах подтверждено отсутствие коллизий и аккуратное центрирование камеры над карточкой фокуса.</a:t>
+              <a:t>Слайд 4: Fennec Broadcast — эталонный пак по чистоте верстки. На скриншоте показан прозрачный радар и статический 2D-фолбэк агента террористов при отсутствии видеопотока (не вебкамера, без наложения фейкового геймплея). Аккуратное центрирование камеры над карточкой фокуса.</a:t>
             </a:r>
           </a:p>
         </p:txBody>
@@ -861,7 +1074,7 @@
           <a:lstStyle/>
           <a:p>
             <a:r>
-              <a:t>Слайд 5: Стиль Championship. Подчеркнуть честный статус: в ходе тестирования была проверена геометрия ростеров при длинных никнеймах (ELECTRONIC, PLAYERT HREE и др.). Инструментальные замеры Range.getClientRects подтвердили стабильную однострочную верстку.</a:t>
+              <a:t>Слайд 5: Стиль Championship. Скриншот фиксирует прозрачный радар и статический 2D-фолбэк агента спецназа (SAS) вместо видеопотока веб-камеры (без фейкового фона геймплея). Подтверждена стабильная однострочная верстка ростеров при длинных никнеймах игроков.</a:t>
             </a:r>
           </a:p>
         </p:txBody>
@@ -931,7 +1144,7 @@
           <a:lstStyle/>
           <a:p>
             <a:r>
-              <a:t>Слайд 6: Архитектура вебкамер. Главное преимущество — оверлей никогда не выглядит сломанным или пустым. Если физической камеры нет, зритель видит агента. Если камера подключена — она идеально встает в вырез.</a:t>
+              <a:t>Слайд 6: Архитектура вебкамер. Главное преимущество — оверлей никогда не выглядит сломанным или пустым. Если физической камеры нет, зритель видит статический аватар агента CS2 (надежный фолбэк). Если камера подключена — она идеально встает в вырез.</a:t>
             </a:r>
           </a:p>
         </p:txBody>
@@ -4809,7 +5022,7 @@
               </a:defRPr>
             </a:pPr>
             <a:r>
-              <a:t>01 / 10</a:t>
+              <a:t>01 / 13</a:t>
             </a:r>
           </a:p>
         </p:txBody>
@@ -5407,7 +5620,2073 @@
               </a:defRPr>
             </a:pPr>
             <a:r>
-              <a:t>10 / 10</a:t>
+              <a:t>10 / 13</a:t>
+            </a:r>
+          </a:p>
+        </p:txBody>
+      </p:sp>
+    </p:spTree>
+  </p:cSld>
+  <p:clrMapOvr>
+    <a:masterClrMapping/>
+  </p:clrMapOvr>
+</p:sld>
+</file>
+
+<file path=ppt/slides/slide11.xml><?xml version="1.0" encoding="utf-8"?>
+<p:sld xmlns:a="http://schemas.openxmlformats.org/drawingml/2006/main" xmlns:p="http://schemas.openxmlformats.org/presentationml/2006/main" xmlns:r="http://schemas.openxmlformats.org/officeDocument/2006/relationships">
+  <p:cSld>
+    <p:bg>
+      <p:bgPr>
+        <a:solidFill>
+          <a:srgbClr val="0B0E14"/>
+        </a:solidFill>
+        <a:effectLst/>
+      </p:bgPr>
+    </p:bg>
+    <p:spTree>
+      <p:nvGrpSpPr>
+        <p:cNvPr id="1" name=""/>
+        <p:cNvGrpSpPr/>
+        <p:nvPr/>
+      </p:nvGrpSpPr>
+      <p:grpSpPr/>
+      <p:sp>
+        <p:nvSpPr>
+          <p:cNvPr id="2" name="TextBox 1"/>
+          <p:cNvSpPr txBox="1"/>
+          <p:nvPr/>
+        </p:nvSpPr>
+        <p:spPr>
+          <a:xfrm>
+            <a:off x="731520" y="365760"/>
+            <a:ext cx="10728655" cy="256032"/>
+          </a:xfrm>
+          <a:prstGeom prst="rect">
+            <a:avLst/>
+          </a:prstGeom>
+          <a:noFill/>
+        </p:spPr>
+        <p:txBody>
+          <a:bodyPr wrap="square" lIns="0" tIns="0" rIns="0" bIns="0">
+            <a:spAutoFit/>
+          </a:bodyPr>
+          <a:lstStyle/>
+          <a:p>
+            <a:pPr>
+              <a:defRPr sz="950" b="1">
+                <a:solidFill>
+                  <a:srgbClr val="00E5FF"/>
+                </a:solidFill>
+              </a:defRPr>
+            </a:pPr>
+            <a:r>
+              <a:t>РАЗВЁРТЫВАНИЕ И ТЕЛЕМЕТРИЯ  •  PRACTICAL ONBOARDING</a:t>
+            </a:r>
+          </a:p>
+        </p:txBody>
+      </p:sp>
+      <p:sp>
+        <p:nvSpPr>
+          <p:cNvPr id="3" name="TextBox 2"/>
+          <p:cNvSpPr txBox="1"/>
+          <p:nvPr/>
+        </p:nvSpPr>
+        <p:spPr>
+          <a:xfrm>
+            <a:off x="731520" y="621792"/>
+            <a:ext cx="10728655" cy="502920"/>
+          </a:xfrm>
+          <a:prstGeom prst="rect">
+            <a:avLst/>
+          </a:prstGeom>
+          <a:noFill/>
+        </p:spPr>
+        <p:txBody>
+          <a:bodyPr wrap="square" lIns="0" tIns="0" rIns="0" bIns="0">
+            <a:spAutoFit/>
+          </a:bodyPr>
+          <a:lstStyle/>
+          <a:p>
+            <a:pPr>
+              <a:defRPr sz="2100" b="1">
+                <a:solidFill>
+                  <a:srgbClr val="F8FAFC"/>
+                </a:solidFill>
+              </a:defRPr>
+            </a:pPr>
+            <a:r>
+              <a:t>Установка, запуск и интеграция CS2 GSI</a:t>
+            </a:r>
+          </a:p>
+        </p:txBody>
+      </p:sp>
+      <p:sp>
+        <p:nvSpPr>
+          <p:cNvPr id="4" name="TextBox 3"/>
+          <p:cNvSpPr txBox="1"/>
+          <p:nvPr/>
+        </p:nvSpPr>
+        <p:spPr>
+          <a:xfrm>
+            <a:off x="731520" y="1133856"/>
+            <a:ext cx="10728655" cy="347472"/>
+          </a:xfrm>
+          <a:prstGeom prst="rect">
+            <a:avLst/>
+          </a:prstGeom>
+          <a:noFill/>
+        </p:spPr>
+        <p:txBody>
+          <a:bodyPr wrap="square" lIns="0" tIns="0" rIns="0" bIns="0">
+            <a:spAutoFit/>
+          </a:bodyPr>
+          <a:lstStyle/>
+          <a:p>
+            <a:pPr>
+              <a:defRPr sz="1100">
+                <a:solidFill>
+                  <a:srgbClr val="94A3B8"/>
+                </a:solidFill>
+              </a:defRPr>
+            </a:pPr>
+            <a:r>
+              <a:t>Развёртывание бинарника v0.1.0, авто-конфигурация CS2 cfg и ключевое разделение потоков наблюдателя</a:t>
+            </a:r>
+          </a:p>
+        </p:txBody>
+      </p:sp>
+      <p:sp>
+        <p:nvSpPr>
+          <p:cNvPr id="5" name="Rounded Rectangle 4"/>
+          <p:cNvSpPr/>
+          <p:nvPr/>
+        </p:nvSpPr>
+        <p:spPr>
+          <a:xfrm>
+            <a:off x="731520" y="1600200"/>
+            <a:ext cx="3383280" cy="4480560"/>
+          </a:xfrm>
+          <a:prstGeom prst="roundRect">
+            <a:avLst/>
+          </a:prstGeom>
+          <a:solidFill>
+            <a:srgbClr val="131822"/>
+          </a:solidFill>
+          <a:ln w="12700">
+            <a:solidFill>
+              <a:srgbClr val="263042"/>
+            </a:solidFill>
+          </a:ln>
+        </p:spPr>
+        <p:style>
+          <a:lnRef idx="1">
+            <a:schemeClr val="accent1"/>
+          </a:lnRef>
+          <a:fillRef idx="3">
+            <a:schemeClr val="accent1"/>
+          </a:fillRef>
+          <a:effectRef idx="2">
+            <a:schemeClr val="accent1"/>
+          </a:effectRef>
+          <a:fontRef idx="minor">
+            <a:schemeClr val="lt1"/>
+          </a:fontRef>
+        </p:style>
+        <p:txBody>
+          <a:bodyPr rtlCol="0" anchor="ctr"/>
+          <a:lstStyle/>
+          <a:p>
+            <a:pPr algn="ctr"/>
+          </a:p>
+        </p:txBody>
+      </p:sp>
+      <p:sp>
+        <p:nvSpPr>
+          <p:cNvPr id="6" name="TextBox 5"/>
+          <p:cNvSpPr txBox="1"/>
+          <p:nvPr/>
+        </p:nvSpPr>
+        <p:spPr>
+          <a:xfrm>
+            <a:off x="914400" y="1783080"/>
+            <a:ext cx="3017520" cy="4114800"/>
+          </a:xfrm>
+          <a:prstGeom prst="rect">
+            <a:avLst/>
+          </a:prstGeom>
+          <a:noFill/>
+        </p:spPr>
+        <p:txBody>
+          <a:bodyPr wrap="square">
+            <a:spAutoFit/>
+          </a:bodyPr>
+          <a:lstStyle/>
+          <a:p>
+            <a:pPr>
+              <a:defRPr sz="1100" b="1">
+                <a:solidFill>
+                  <a:srgbClr val="00E5FF"/>
+                </a:solidFill>
+              </a:defRPr>
+            </a:pPr>
+            <a:r>
+              <a:t>1. ЗАПУСК И ПУТИ ДАННЫХ</a:t>
+            </a:r>
+          </a:p>
+          <a:p>
+            <a:pPr>
+              <a:defRPr sz="950" b="1">
+                <a:solidFill>
+                  <a:srgbClr val="00E5FF"/>
+                </a:solidFill>
+              </a:defRPr>
+            </a:pPr>
+            <a:r>
+              <a:t>• Бинарник: </a:t>
+            </a:r>
+          </a:p>
+          <a:p>
+            <a:pPr>
+              <a:defRPr sz="850">
+                <a:solidFill>
+                  <a:srgbClr val="CBD5E1"/>
+                </a:solidFill>
+              </a:defRPr>
+            </a:pPr>
+            <a:r>
+              <a:t>Запуск protokol-hud-manager.exe (18.8 МБ). SmartScreen: «Подробнее» → «Выполнить в любом случае».</a:t>
+            </a:r>
+          </a:p>
+          <a:p>
+            <a:pPr>
+              <a:defRPr sz="950" b="1">
+                <a:solidFill>
+                  <a:srgbClr val="00E5FF"/>
+                </a:solidFill>
+              </a:defRPr>
+            </a:pPr>
+            <a:r>
+              <a:t>• База данных SQLite WAL: </a:t>
+            </a:r>
+          </a:p>
+          <a:p>
+            <a:pPr>
+              <a:defRPr sz="850">
+                <a:solidFill>
+                  <a:srgbClr val="CBD5E1"/>
+                </a:solidFill>
+              </a:defRPr>
+            </a:pPr>
+            <a:r>
+              <a:t>Автосоздание рабочей БД %APPDATA%\PROTOKOL HUD\protokol.db со всеми таблицами при старте.</a:t>
+            </a:r>
+          </a:p>
+          <a:p>
+            <a:pPr>
+              <a:defRPr sz="950" b="1">
+                <a:solidFill>
+                  <a:srgbClr val="00E5FF"/>
+                </a:solidFill>
+              </a:defRPr>
+            </a:pPr>
+            <a:r>
+              <a:t>• Сетевой порт ядра :1349: </a:t>
+            </a:r>
+          </a:p>
+          <a:p>
+            <a:pPr>
+              <a:defRPr sz="850">
+                <a:solidFill>
+                  <a:srgbClr val="CBD5E1"/>
+                </a:solidFill>
+              </a:defRPr>
+            </a:pPr>
+            <a:r>
+              <a:t>HTTP/WebSocket сервер слушает http://127.0.0.1:1349 с автоперебором fallback-портов до :1359.</a:t>
+            </a:r>
+          </a:p>
+          <a:p>
+            <a:pPr>
+              <a:defRPr sz="950" b="1">
+                <a:solidFill>
+                  <a:srgbClr val="00E5FF"/>
+                </a:solidFill>
+              </a:defRPr>
+            </a:pPr>
+            <a:r>
+              <a:t>• Каталог оверлеев: </a:t>
+            </a:r>
+          </a:p>
+          <a:p>
+            <a:pPr>
+              <a:defRPr sz="850">
+                <a:solidFill>
+                  <a:srgbClr val="CBD5E1"/>
+                </a:solidFill>
+              </a:defRPr>
+            </a:pPr>
+            <a:r>
+              <a:t>Паки раздаются строго из %APPDATA%\PROTOKOL HUD\overlays\ по URL /overlay/&lt;pack&gt;/.</a:t>
+            </a:r>
+          </a:p>
+        </p:txBody>
+      </p:sp>
+      <p:sp>
+        <p:nvSpPr>
+          <p:cNvPr id="7" name="Rounded Rectangle 6"/>
+          <p:cNvSpPr/>
+          <p:nvPr/>
+        </p:nvSpPr>
+        <p:spPr>
+          <a:xfrm>
+            <a:off x="4389120" y="1600200"/>
+            <a:ext cx="3383280" cy="4480560"/>
+          </a:xfrm>
+          <a:prstGeom prst="roundRect">
+            <a:avLst/>
+          </a:prstGeom>
+          <a:solidFill>
+            <a:srgbClr val="131822"/>
+          </a:solidFill>
+          <a:ln w="12700">
+            <a:solidFill>
+              <a:srgbClr val="263042"/>
+            </a:solidFill>
+          </a:ln>
+        </p:spPr>
+        <p:style>
+          <a:lnRef idx="1">
+            <a:schemeClr val="accent1"/>
+          </a:lnRef>
+          <a:fillRef idx="3">
+            <a:schemeClr val="accent1"/>
+          </a:fillRef>
+          <a:effectRef idx="2">
+            <a:schemeClr val="accent1"/>
+          </a:effectRef>
+          <a:fontRef idx="minor">
+            <a:schemeClr val="lt1"/>
+          </a:fontRef>
+        </p:style>
+        <p:txBody>
+          <a:bodyPr rtlCol="0" anchor="ctr"/>
+          <a:lstStyle/>
+          <a:p>
+            <a:pPr algn="ctr"/>
+          </a:p>
+        </p:txBody>
+      </p:sp>
+      <p:sp>
+        <p:nvSpPr>
+          <p:cNvPr id="8" name="TextBox 7"/>
+          <p:cNvSpPr txBox="1"/>
+          <p:nvPr/>
+        </p:nvSpPr>
+        <p:spPr>
+          <a:xfrm>
+            <a:off x="4572000" y="1783080"/>
+            <a:ext cx="3017520" cy="4114800"/>
+          </a:xfrm>
+          <a:prstGeom prst="rect">
+            <a:avLst/>
+          </a:prstGeom>
+          <a:noFill/>
+        </p:spPr>
+        <p:txBody>
+          <a:bodyPr wrap="square">
+            <a:spAutoFit/>
+          </a:bodyPr>
+          <a:lstStyle/>
+          <a:p>
+            <a:pPr>
+              <a:defRPr sz="1100" b="1">
+                <a:solidFill>
+                  <a:srgbClr val="E5B869"/>
+                </a:solidFill>
+              </a:defRPr>
+            </a:pPr>
+            <a:r>
+              <a:t>2. КОНФИГУРАЦИЯ CS2 GSI</a:t>
+            </a:r>
+          </a:p>
+          <a:p>
+            <a:pPr>
+              <a:defRPr sz="950" b="1">
+                <a:solidFill>
+                  <a:srgbClr val="E5B869"/>
+                </a:solidFill>
+              </a:defRPr>
+            </a:pPr>
+            <a:r>
+              <a:t>• Автопоиск каталога CS2: </a:t>
+            </a:r>
+          </a:p>
+          <a:p>
+            <a:pPr>
+              <a:defRPr sz="850">
+                <a:solidFill>
+                  <a:srgbClr val="CBD5E1"/>
+                </a:solidFill>
+              </a:defRPr>
+            </a:pPr>
+            <a:r>
+              <a:t>Кнопка «Установить GSI cfg в CS2» в Настройках автоматически находит путь к игре на дисках C:..Z:.</a:t>
+            </a:r>
+          </a:p>
+          <a:p>
+            <a:pPr>
+              <a:defRPr sz="950" b="1">
+                <a:solidFill>
+                  <a:srgbClr val="E5B869"/>
+                </a:solidFill>
+              </a:defRPr>
+            </a:pPr>
+            <a:r>
+              <a:t>• Точный путь к cfg: </a:t>
+            </a:r>
+          </a:p>
+          <a:p>
+            <a:pPr>
+              <a:defRPr sz="850">
+                <a:solidFill>
+                  <a:srgbClr val="CBD5E1"/>
+                </a:solidFill>
+              </a:defRPr>
+            </a:pPr>
+            <a:r>
+              <a:t>Создается в &lt;Steam&gt;\...\game\csgo\cfg\gamestate_integration_protokol.cfg с URI /api/gsi.</a:t>
+            </a:r>
+          </a:p>
+          <a:p>
+            <a:pPr>
+              <a:defRPr sz="950" b="1">
+                <a:solidFill>
+                  <a:srgbClr val="E5B869"/>
+                </a:solidFill>
+              </a:defRPr>
+            </a:pPr>
+            <a:r>
+              <a:t>• Авторизация auth.token: </a:t>
+            </a:r>
+          </a:p>
+          <a:p>
+            <a:pPr>
+              <a:defRPr sz="850">
+                <a:solidFill>
+                  <a:srgbClr val="CBD5E1"/>
+                </a:solidFill>
+              </a:defRPr>
+            </a:pPr>
+            <a:r>
+              <a:t>UUID v4 токен генерируется в таблице настроек и отсекает посторонний трафик (401 Unauthorized).</a:t>
+            </a:r>
+          </a:p>
+          <a:p>
+            <a:pPr>
+              <a:defRPr sz="950" b="1">
+                <a:solidFill>
+                  <a:srgbClr val="E5B869"/>
+                </a:solidFill>
+              </a:defRPr>
+            </a:pPr>
+            <a:r>
+              <a:t>• Холодный старт CS2: </a:t>
+            </a:r>
+          </a:p>
+          <a:p>
+            <a:pPr>
+              <a:defRPr sz="850">
+                <a:solidFill>
+                  <a:srgbClr val="CBD5E1"/>
+                </a:solidFill>
+              </a:defRPr>
+            </a:pPr>
+            <a:r>
+              <a:t>CS2 считывает GSI-конфиги только при старте: если игра была открыта, требуется полный перезапуск.</a:t>
+            </a:r>
+          </a:p>
+        </p:txBody>
+      </p:sp>
+      <p:sp>
+        <p:nvSpPr>
+          <p:cNvPr id="9" name="Rounded Rectangle 8"/>
+          <p:cNvSpPr/>
+          <p:nvPr/>
+        </p:nvSpPr>
+        <p:spPr>
+          <a:xfrm>
+            <a:off x="8046720" y="1600200"/>
+            <a:ext cx="3383280" cy="4480560"/>
+          </a:xfrm>
+          <a:prstGeom prst="roundRect">
+            <a:avLst/>
+          </a:prstGeom>
+          <a:solidFill>
+            <a:srgbClr val="131822"/>
+          </a:solidFill>
+          <a:ln w="12700">
+            <a:solidFill>
+              <a:srgbClr val="263042"/>
+            </a:solidFill>
+          </a:ln>
+        </p:spPr>
+        <p:style>
+          <a:lnRef idx="1">
+            <a:schemeClr val="accent1"/>
+          </a:lnRef>
+          <a:fillRef idx="3">
+            <a:schemeClr val="accent1"/>
+          </a:fillRef>
+          <a:effectRef idx="2">
+            <a:schemeClr val="accent1"/>
+          </a:effectRef>
+          <a:fontRef idx="minor">
+            <a:schemeClr val="lt1"/>
+          </a:fontRef>
+        </p:style>
+        <p:txBody>
+          <a:bodyPr rtlCol="0" anchor="ctr"/>
+          <a:lstStyle/>
+          <a:p>
+            <a:pPr algn="ctr"/>
+          </a:p>
+        </p:txBody>
+      </p:sp>
+      <p:sp>
+        <p:nvSpPr>
+          <p:cNvPr id="10" name="TextBox 9"/>
+          <p:cNvSpPr txBox="1"/>
+          <p:nvPr/>
+        </p:nvSpPr>
+        <p:spPr>
+          <a:xfrm>
+            <a:off x="8229600" y="1783080"/>
+            <a:ext cx="3017520" cy="4114800"/>
+          </a:xfrm>
+          <a:prstGeom prst="rect">
+            <a:avLst/>
+          </a:prstGeom>
+          <a:noFill/>
+        </p:spPr>
+        <p:txBody>
+          <a:bodyPr wrap="square">
+            <a:spAutoFit/>
+          </a:bodyPr>
+          <a:lstStyle/>
+          <a:p>
+            <a:pPr>
+              <a:defRPr sz="1100" b="1">
+                <a:solidFill>
+                  <a:srgbClr val="3B82F6"/>
+                </a:solidFill>
+              </a:defRPr>
+            </a:pPr>
+            <a:r>
+              <a:t>3. НАБЛЮДАТЕЛЬ VS POV / DEDICATED</a:t>
+            </a:r>
+          </a:p>
+          <a:p>
+            <a:pPr>
+              <a:defRPr sz="950" b="1">
+                <a:solidFill>
+                  <a:srgbClr val="3B82F6"/>
+                </a:solidFill>
+              </a:defRPr>
+            </a:pPr>
+            <a:r>
+              <a:t>• Клиент наблюдателя (GOTV): </a:t>
+            </a:r>
+          </a:p>
+          <a:p>
+            <a:pPr>
+              <a:defRPr sz="850">
+                <a:solidFill>
+                  <a:srgbClr val="CBD5E1"/>
+                </a:solidFill>
+              </a:defRPr>
+            </a:pPr>
+            <a:r>
+              <a:t>ОБЯЗАТЕЛЬНО: только спектатор получает от CS2 полный дамп allplayers_* по 10 игрокам.</a:t>
+            </a:r>
+          </a:p>
+          <a:p>
+            <a:pPr>
+              <a:defRPr sz="950" b="1">
+                <a:solidFill>
+                  <a:srgbClr val="3B82F6"/>
+                </a:solidFill>
+              </a:defRPr>
+            </a:pPr>
+            <a:r>
+              <a:t>• Ограничение POV-клиента: </a:t>
+            </a:r>
+          </a:p>
+          <a:p>
+            <a:pPr>
+              <a:defRPr sz="850">
+                <a:solidFill>
+                  <a:srgbClr val="CBD5E1"/>
+                </a:solidFill>
+              </a:defRPr>
+            </a:pPr>
+            <a:r>
+              <a:t>Клиент обычного игрока из античит-соображений не шлет чужие данные: оверлей и радар останутся пустыми.</a:t>
+            </a:r>
+          </a:p>
+          <a:p>
+            <a:pPr>
+              <a:defRPr sz="950" b="1">
+                <a:solidFill>
+                  <a:srgbClr val="3B82F6"/>
+                </a:solidFill>
+              </a:defRPr>
+            </a:pPr>
+            <a:r>
+              <a:t>• Выделенный сервер: </a:t>
+            </a:r>
+          </a:p>
+          <a:p>
+            <a:pPr>
+              <a:defRPr sz="850">
+                <a:solidFill>
+                  <a:srgbClr val="CBD5E1"/>
+                </a:solidFill>
+              </a:defRPr>
+            </a:pPr>
+            <a:r>
+              <a:t>Прямой GSI с Dedicated Server возможен, но для локального вещания стандартом является клиент обсервера.</a:t>
+            </a:r>
+          </a:p>
+          <a:p>
+            <a:pPr>
+              <a:defRPr sz="950" b="1">
+                <a:solidFill>
+                  <a:srgbClr val="3B82F6"/>
+                </a:solidFill>
+              </a:defRPr>
+            </a:pPr>
+            <a:r>
+              <a:t>• Сетевой обсервер: </a:t>
+            </a:r>
+          </a:p>
+          <a:p>
+            <a:pPr>
+              <a:defRPr sz="850">
+                <a:solidFill>
+                  <a:srgbClr val="CBD5E1"/>
+                </a:solidFill>
+              </a:defRPr>
+            </a:pPr>
+            <a:r>
+              <a:t>При отдельном ПК обсервера в cfg указывается IP эфирного ПК и открывается порт 1349 TCP в Firewall.</a:t>
+            </a:r>
+          </a:p>
+        </p:txBody>
+      </p:sp>
+      <p:sp>
+        <p:nvSpPr>
+          <p:cNvPr id="11" name="Rectangle 10"/>
+          <p:cNvSpPr/>
+          <p:nvPr/>
+        </p:nvSpPr>
+        <p:spPr>
+          <a:xfrm>
+            <a:off x="731520" y="6400800"/>
+            <a:ext cx="10728655" cy="10972"/>
+          </a:xfrm>
+          <a:prstGeom prst="rect">
+            <a:avLst/>
+          </a:prstGeom>
+          <a:solidFill>
+            <a:srgbClr val="263042"/>
+          </a:solidFill>
+          <a:ln>
+            <a:solidFill>
+              <a:srgbClr val="263042"/>
+            </a:solidFill>
+          </a:ln>
+        </p:spPr>
+        <p:style>
+          <a:lnRef idx="1">
+            <a:schemeClr val="accent1"/>
+          </a:lnRef>
+          <a:fillRef idx="3">
+            <a:schemeClr val="accent1"/>
+          </a:fillRef>
+          <a:effectRef idx="2">
+            <a:schemeClr val="accent1"/>
+          </a:effectRef>
+          <a:fontRef idx="minor">
+            <a:schemeClr val="lt1"/>
+          </a:fontRef>
+        </p:style>
+        <p:txBody>
+          <a:bodyPr rtlCol="0" anchor="ctr"/>
+          <a:lstStyle/>
+          <a:p>
+            <a:pPr algn="ctr"/>
+          </a:p>
+        </p:txBody>
+      </p:sp>
+      <p:sp>
+        <p:nvSpPr>
+          <p:cNvPr id="12" name="TextBox 11"/>
+          <p:cNvSpPr txBox="1"/>
+          <p:nvPr/>
+        </p:nvSpPr>
+        <p:spPr>
+          <a:xfrm>
+            <a:off x="731520" y="6455664"/>
+            <a:ext cx="8229600" cy="256032"/>
+          </a:xfrm>
+          <a:prstGeom prst="rect">
+            <a:avLst/>
+          </a:prstGeom>
+          <a:noFill/>
+        </p:spPr>
+        <p:txBody>
+          <a:bodyPr wrap="none" lIns="0" tIns="0" rIns="0" bIns="0">
+            <a:spAutoFit/>
+          </a:bodyPr>
+          <a:lstStyle/>
+          <a:p>
+            <a:pPr>
+              <a:defRPr sz="850">
+                <a:solidFill>
+                  <a:srgbClr val="64748B"/>
+                </a:solidFill>
+              </a:defRPr>
+            </a:pPr>
+            <a:r>
+              <a:t>PROTOKOL HUD Manager  •  Комплекс CS2 турнирных трансляций  •  Версия v0.1.0</a:t>
+            </a:r>
+          </a:p>
+        </p:txBody>
+      </p:sp>
+      <p:sp>
+        <p:nvSpPr>
+          <p:cNvPr id="13" name="TextBox 12"/>
+          <p:cNvSpPr txBox="1"/>
+          <p:nvPr/>
+        </p:nvSpPr>
+        <p:spPr>
+          <a:xfrm>
+            <a:off x="9601200" y="6455664"/>
+            <a:ext cx="1858975" cy="256032"/>
+          </a:xfrm>
+          <a:prstGeom prst="rect">
+            <a:avLst/>
+          </a:prstGeom>
+          <a:noFill/>
+        </p:spPr>
+        <p:txBody>
+          <a:bodyPr wrap="none" lIns="0" tIns="0" rIns="0" bIns="0">
+            <a:spAutoFit/>
+          </a:bodyPr>
+          <a:lstStyle/>
+          <a:p>
+            <a:pPr algn="r">
+              <a:defRPr sz="850" b="1">
+                <a:solidFill>
+                  <a:srgbClr val="E5B869"/>
+                </a:solidFill>
+              </a:defRPr>
+            </a:pPr>
+            <a:r>
+              <a:t>11 / 13</a:t>
+            </a:r>
+          </a:p>
+        </p:txBody>
+      </p:sp>
+    </p:spTree>
+  </p:cSld>
+  <p:clrMapOvr>
+    <a:masterClrMapping/>
+  </p:clrMapOvr>
+</p:sld>
+</file>
+
+<file path=ppt/slides/slide12.xml><?xml version="1.0" encoding="utf-8"?>
+<p:sld xmlns:a="http://schemas.openxmlformats.org/drawingml/2006/main" xmlns:p="http://schemas.openxmlformats.org/presentationml/2006/main" xmlns:r="http://schemas.openxmlformats.org/officeDocument/2006/relationships">
+  <p:cSld>
+    <p:bg>
+      <p:bgPr>
+        <a:solidFill>
+          <a:srgbClr val="0B0E14"/>
+        </a:solidFill>
+        <a:effectLst/>
+      </p:bgPr>
+    </p:bg>
+    <p:spTree>
+      <p:nvGrpSpPr>
+        <p:cNvPr id="1" name=""/>
+        <p:cNvGrpSpPr/>
+        <p:nvPr/>
+      </p:nvGrpSpPr>
+      <p:grpSpPr/>
+      <p:sp>
+        <p:nvSpPr>
+          <p:cNvPr id="2" name="TextBox 1"/>
+          <p:cNvSpPr txBox="1"/>
+          <p:nvPr/>
+        </p:nvSpPr>
+        <p:spPr>
+          <a:xfrm>
+            <a:off x="731520" y="365760"/>
+            <a:ext cx="10728655" cy="256032"/>
+          </a:xfrm>
+          <a:prstGeom prst="rect">
+            <a:avLst/>
+          </a:prstGeom>
+          <a:noFill/>
+        </p:spPr>
+        <p:txBody>
+          <a:bodyPr wrap="square" lIns="0" tIns="0" rIns="0" bIns="0">
+            <a:spAutoFit/>
+          </a:bodyPr>
+          <a:lstStyle/>
+          <a:p>
+            <a:pPr>
+              <a:defRPr sz="950" b="1">
+                <a:solidFill>
+                  <a:srgbClr val="3B82F6"/>
+                </a:solidFill>
+              </a:defRPr>
+            </a:pPr>
+            <a:r>
+              <a:t>ЭФИРНЫЙ СЕТАП  •  PRODUCTION &amp; PACK MANAGEMENT</a:t>
+            </a:r>
+          </a:p>
+        </p:txBody>
+      </p:sp>
+      <p:sp>
+        <p:nvSpPr>
+          <p:cNvPr id="3" name="TextBox 2"/>
+          <p:cNvSpPr txBox="1"/>
+          <p:nvPr/>
+        </p:nvSpPr>
+        <p:spPr>
+          <a:xfrm>
+            <a:off x="731520" y="621792"/>
+            <a:ext cx="10728655" cy="502920"/>
+          </a:xfrm>
+          <a:prstGeom prst="rect">
+            <a:avLst/>
+          </a:prstGeom>
+          <a:noFill/>
+        </p:spPr>
+        <p:txBody>
+          <a:bodyPr wrap="square" lIns="0" tIns="0" rIns="0" bIns="0">
+            <a:spAutoFit/>
+          </a:bodyPr>
+          <a:lstStyle/>
+          <a:p>
+            <a:pPr>
+              <a:defRPr sz="2100" b="1">
+                <a:solidFill>
+                  <a:srgbClr val="F8FAFC"/>
+                </a:solidFill>
+              </a:defRPr>
+            </a:pPr>
+            <a:r>
+              <a:t>Настройка OBS Studio и управление HUD-паками</a:t>
+            </a:r>
+          </a:p>
+        </p:txBody>
+      </p:sp>
+      <p:sp>
+        <p:nvSpPr>
+          <p:cNvPr id="4" name="TextBox 3"/>
+          <p:cNvSpPr txBox="1"/>
+          <p:nvPr/>
+        </p:nvSpPr>
+        <p:spPr>
+          <a:xfrm>
+            <a:off x="731520" y="1133856"/>
+            <a:ext cx="10728655" cy="347472"/>
+          </a:xfrm>
+          <a:prstGeom prst="rect">
+            <a:avLst/>
+          </a:prstGeom>
+          <a:noFill/>
+        </p:spPr>
+        <p:txBody>
+          <a:bodyPr wrap="square" lIns="0" tIns="0" rIns="0" bIns="0">
+            <a:spAutoFit/>
+          </a:bodyPr>
+          <a:lstStyle/>
+          <a:p>
+            <a:pPr>
+              <a:defRPr sz="1100">
+                <a:solidFill>
+                  <a:srgbClr val="94A3B8"/>
+                </a:solidFill>
+              </a:defRPr>
+            </a:pPr>
+            <a:r>
+              <a:t>Параметры Browser Source, прозрачный альфа-канал, защита WebSocket и безопасный импорт оверлеев из ZIP</a:t>
+            </a:r>
+          </a:p>
+        </p:txBody>
+      </p:sp>
+      <p:sp>
+        <p:nvSpPr>
+          <p:cNvPr id="5" name="Rounded Rectangle 4"/>
+          <p:cNvSpPr/>
+          <p:nvPr/>
+        </p:nvSpPr>
+        <p:spPr>
+          <a:xfrm>
+            <a:off x="731520" y="1600200"/>
+            <a:ext cx="5212080" cy="4480560"/>
+          </a:xfrm>
+          <a:prstGeom prst="roundRect">
+            <a:avLst/>
+          </a:prstGeom>
+          <a:solidFill>
+            <a:srgbClr val="131822"/>
+          </a:solidFill>
+          <a:ln w="12700">
+            <a:solidFill>
+              <a:srgbClr val="263042"/>
+            </a:solidFill>
+          </a:ln>
+        </p:spPr>
+        <p:style>
+          <a:lnRef idx="1">
+            <a:schemeClr val="accent1"/>
+          </a:lnRef>
+          <a:fillRef idx="3">
+            <a:schemeClr val="accent1"/>
+          </a:fillRef>
+          <a:effectRef idx="2">
+            <a:schemeClr val="accent1"/>
+          </a:effectRef>
+          <a:fontRef idx="minor">
+            <a:schemeClr val="lt1"/>
+          </a:fontRef>
+        </p:style>
+        <p:txBody>
+          <a:bodyPr rtlCol="0" anchor="ctr"/>
+          <a:lstStyle/>
+          <a:p>
+            <a:pPr algn="ctr"/>
+          </a:p>
+        </p:txBody>
+      </p:sp>
+      <p:sp>
+        <p:nvSpPr>
+          <p:cNvPr id="6" name="TextBox 5"/>
+          <p:cNvSpPr txBox="1"/>
+          <p:nvPr/>
+        </p:nvSpPr>
+        <p:spPr>
+          <a:xfrm>
+            <a:off x="914400" y="1783080"/>
+            <a:ext cx="4846320" cy="4114800"/>
+          </a:xfrm>
+          <a:prstGeom prst="rect">
+            <a:avLst/>
+          </a:prstGeom>
+          <a:noFill/>
+        </p:spPr>
+        <p:txBody>
+          <a:bodyPr wrap="square">
+            <a:spAutoFit/>
+          </a:bodyPr>
+          <a:lstStyle/>
+          <a:p>
+            <a:pPr>
+              <a:defRPr sz="1100" b="1">
+                <a:solidFill>
+                  <a:srgbClr val="3B82F6"/>
+                </a:solidFill>
+              </a:defRPr>
+            </a:pPr>
+            <a:r>
+              <a:t>ИНТЕГРАЦИЯ В OBS STUDIO (BROWSER SOURCE)</a:t>
+            </a:r>
+          </a:p>
+          <a:p>
+            <a:pPr>
+              <a:defRPr sz="950" b="1">
+                <a:solidFill>
+                  <a:srgbClr val="3B82F6"/>
+                </a:solidFill>
+              </a:defRPr>
+            </a:pPr>
+            <a:r>
+              <a:t>• Параметры Browser Source: </a:t>
+            </a:r>
+          </a:p>
+          <a:p>
+            <a:pPr>
+              <a:defRPr sz="850">
+                <a:solidFill>
+                  <a:srgbClr val="CBD5E1"/>
+                </a:solidFill>
+              </a:defRPr>
+            </a:pPr>
+            <a:r>
+              <a:t>URL: http://127.0.0.1:1349/overlay/&lt;pack&gt;/index.html. Разрешение строго 1920×1080 @ 60 FPS, поле Custom CSS оставить пустым.</a:t>
+            </a:r>
+          </a:p>
+          <a:p>
+            <a:pPr>
+              <a:defRPr sz="950" b="1">
+                <a:solidFill>
+                  <a:srgbClr val="3B82F6"/>
+                </a:solidFill>
+              </a:defRPr>
+            </a:pPr>
+            <a:r>
+              <a:t>• Критический флаг: Источник видим: </a:t>
+            </a:r>
+          </a:p>
+          <a:p>
+            <a:pPr>
+              <a:defRPr sz="850">
+                <a:solidFill>
+                  <a:srgbClr val="CBD5E1"/>
+                </a:solidFill>
+              </a:defRPr>
+            </a:pPr>
+            <a:r>
+              <a:t>СНИМИТЕ флаг: «Завершать захват, когда источник невидим». Иначе при смене сцен рвется сокет /ws и HUD заново инициализируется с задержкой.</a:t>
+            </a:r>
+          </a:p>
+          <a:p>
+            <a:pPr>
+              <a:defRPr sz="950" b="1">
+                <a:solidFill>
+                  <a:srgbClr val="3B82F6"/>
+                </a:solidFill>
+              </a:defRPr>
+            </a:pPr>
+            <a:r>
+              <a:t>• Критический флаг: Без перезагрузки: </a:t>
+            </a:r>
+          </a:p>
+          <a:p>
+            <a:pPr>
+              <a:defRPr sz="850">
+                <a:solidFill>
+                  <a:srgbClr val="CBD5E1"/>
+                </a:solidFill>
+              </a:defRPr>
+            </a:pPr>
+            <a:r>
+              <a:t>СНИМИТЕ флаг: «Перезагружать браузер, когда сцена становится активной». Включите аппаратное ускорение браузера в OBS.</a:t>
+            </a:r>
+          </a:p>
+          <a:p>
+            <a:pPr>
+              <a:defRPr sz="950" b="1">
+                <a:solidFill>
+                  <a:srgbClr val="3B82F6"/>
+                </a:solidFill>
+              </a:defRPr>
+            </a:pPr>
+            <a:r>
+              <a:t>• Прозрачный фон и сброс кэша: </a:t>
+            </a:r>
+          </a:p>
+          <a:p>
+            <a:pPr>
+              <a:defRPr sz="850">
+                <a:solidFill>
+                  <a:srgbClr val="CBD5E1"/>
+                </a:solidFill>
+              </a:defRPr>
+            </a:pPr>
+            <a:r>
+              <a:t>Оверлеи имеют background: transparent поверх захвата игры. При обновлении CSS/JS: Правый клик в OBS → «Обновить кэш текущей страницы».</a:t>
+            </a:r>
+          </a:p>
+          <a:p>
+            <a:pPr>
+              <a:defRPr sz="950" b="1">
+                <a:solidFill>
+                  <a:srgbClr val="3B82F6"/>
+                </a:solidFill>
+              </a:defRPr>
+            </a:pPr>
+            <a:r>
+              <a:t>• OBS WebSocket v5 (порт :4455): </a:t>
+            </a:r>
+          </a:p>
+          <a:p>
+            <a:pPr>
+              <a:defRPr sz="850">
+                <a:solidFill>
+                  <a:srgbClr val="CBD5E1"/>
+                </a:solidFill>
+              </a:defRPr>
+            </a:pPr>
+            <a:r>
+              <a:t>Переключение сцен (Match, Casters, Replay) и запуск трансляции/записи напрямую из вкладки «Трансляция» PROTOKOL менеджера.</a:t>
+            </a:r>
+          </a:p>
+        </p:txBody>
+      </p:sp>
+      <p:sp>
+        <p:nvSpPr>
+          <p:cNvPr id="7" name="Rounded Rectangle 6"/>
+          <p:cNvSpPr/>
+          <p:nvPr/>
+        </p:nvSpPr>
+        <p:spPr>
+          <a:xfrm>
+            <a:off x="6217920" y="1600200"/>
+            <a:ext cx="5212080" cy="4480560"/>
+          </a:xfrm>
+          <a:prstGeom prst="roundRect">
+            <a:avLst/>
+          </a:prstGeom>
+          <a:solidFill>
+            <a:srgbClr val="131822"/>
+          </a:solidFill>
+          <a:ln w="12700">
+            <a:solidFill>
+              <a:srgbClr val="263042"/>
+            </a:solidFill>
+          </a:ln>
+        </p:spPr>
+        <p:style>
+          <a:lnRef idx="1">
+            <a:schemeClr val="accent1"/>
+          </a:lnRef>
+          <a:fillRef idx="3">
+            <a:schemeClr val="accent1"/>
+          </a:fillRef>
+          <a:effectRef idx="2">
+            <a:schemeClr val="accent1"/>
+          </a:effectRef>
+          <a:fontRef idx="minor">
+            <a:schemeClr val="lt1"/>
+          </a:fontRef>
+        </p:style>
+        <p:txBody>
+          <a:bodyPr rtlCol="0" anchor="ctr"/>
+          <a:lstStyle/>
+          <a:p>
+            <a:pPr algn="ctr"/>
+          </a:p>
+        </p:txBody>
+      </p:sp>
+      <p:sp>
+        <p:nvSpPr>
+          <p:cNvPr id="8" name="TextBox 7"/>
+          <p:cNvSpPr txBox="1"/>
+          <p:nvPr/>
+        </p:nvSpPr>
+        <p:spPr>
+          <a:xfrm>
+            <a:off x="6400800" y="1783080"/>
+            <a:ext cx="4846320" cy="4114800"/>
+          </a:xfrm>
+          <a:prstGeom prst="rect">
+            <a:avLst/>
+          </a:prstGeom>
+          <a:noFill/>
+        </p:spPr>
+        <p:txBody>
+          <a:bodyPr wrap="square">
+            <a:spAutoFit/>
+          </a:bodyPr>
+          <a:lstStyle/>
+          <a:p>
+            <a:pPr>
+              <a:defRPr sz="1100" b="1">
+                <a:solidFill>
+                  <a:srgbClr val="00E5FF"/>
+                </a:solidFill>
+              </a:defRPr>
+            </a:pPr>
+            <a:r>
+              <a:t>УПРАВЛЕНИЕ И ИМПОРТ HUD-ПАКОВ</a:t>
+            </a:r>
+          </a:p>
+          <a:p>
+            <a:pPr>
+              <a:defRPr sz="950" b="1">
+                <a:solidFill>
+                  <a:srgbClr val="00E5FF"/>
+                </a:solidFill>
+              </a:defRPr>
+            </a:pPr>
+            <a:r>
+              <a:t>• Каталог раздачи в AppData: </a:t>
+            </a:r>
+          </a:p>
+          <a:p>
+            <a:pPr>
+              <a:defRPr sz="850">
+                <a:solidFill>
+                  <a:srgbClr val="CBD5E1"/>
+                </a:solidFill>
+              </a:defRPr>
+            </a:pPr>
+            <a:r>
+              <a:t>Сервер раздает паки из %APPDATA%\PROTOKOL HUD\overlays\&lt;pack&gt;\. Старые паки OpenHUD мигрируют автоматически при старте.</a:t>
+            </a:r>
+          </a:p>
+          <a:p>
+            <a:pPr>
+              <a:defRPr sz="950" b="1">
+                <a:solidFill>
+                  <a:srgbClr val="00E5FF"/>
+                </a:solidFill>
+              </a:defRPr>
+            </a:pPr>
+            <a:r>
+              <a:t>• Импорт паков из ZIP через GUI: </a:t>
+            </a:r>
+          </a:p>
+          <a:p>
+            <a:pPr>
+              <a:defRPr sz="850">
+                <a:solidFill>
+                  <a:srgbClr val="CBD5E1"/>
+                </a:solidFill>
+              </a:defRPr>
+            </a:pPr>
+            <a:r>
+              <a:t>Вкладка «HUD-паки» → поле «Импорт пака из ZIP» → указать путь и нажать «Установить». Встроена защита от Zip-Slip / Path Traversal.</a:t>
+            </a:r>
+          </a:p>
+          <a:p>
+            <a:pPr>
+              <a:defRPr sz="950" b="1">
+                <a:solidFill>
+                  <a:srgbClr val="00E5FF"/>
+                </a:solidFill>
+              </a:defRPr>
+            </a:pPr>
+            <a:r>
+              <a:t>• Структура автономного пака: </a:t>
+            </a:r>
+          </a:p>
+          <a:p>
+            <a:pPr>
+              <a:defRPr sz="850">
+                <a:solidFill>
+                  <a:srgbClr val="CBD5E1"/>
+                </a:solidFill>
+              </a:defRPr>
+            </a:pPr>
+            <a:r>
+              <a:t>Минимум: index.html, hud.js, hud.css, assets/ и radars.json. Подключение общего транспорта: &lt;script src="../_core/core.js"&gt;.</a:t>
+            </a:r>
+          </a:p>
+          <a:p>
+            <a:pPr>
+              <a:defRPr sz="950" b="1">
+                <a:solidFill>
+                  <a:srgbClr val="00E5FF"/>
+                </a:solidFill>
+              </a:defRPr>
+            </a:pPr>
+            <a:r>
+              <a:t>• Мгновенная смена активного HUD: </a:t>
+            </a:r>
+          </a:p>
+          <a:p>
+            <a:pPr>
+              <a:defRPr sz="850">
+                <a:solidFill>
+                  <a:srgbClr val="CBD5E1"/>
+                </a:solidFill>
+              </a:defRPr>
+            </a:pPr>
+            <a:r>
+              <a:t>Выбор стиля в приложении не требует перезапуска OBS: событие hud_activated мгновенно передается открытым оверлеям по WebSocket.</a:t>
+            </a:r>
+          </a:p>
+          <a:p>
+            <a:pPr>
+              <a:defRPr sz="950" b="1">
+                <a:solidFill>
+                  <a:srgbClr val="00E5FF"/>
+                </a:solidFill>
+              </a:defRPr>
+            </a:pPr>
+            <a:r>
+              <a:t>• 3 готовых турнирных стиля: </a:t>
+            </a:r>
+          </a:p>
+          <a:p>
+            <a:pPr>
+              <a:defRPr sz="850">
+                <a:solidFill>
+                  <a:srgbClr val="CBD5E1"/>
+                </a:solidFill>
+              </a:defRPr>
+            </a:pPr>
+            <a:r>
+              <a:t>fennec-cyber (неон/скайлайн), fennec-broadcast (ТВ-таблицы/стекло) и fennec-championship (золото/оникс) полностью готовы к эфиру.</a:t>
+            </a:r>
+          </a:p>
+        </p:txBody>
+      </p:sp>
+      <p:sp>
+        <p:nvSpPr>
+          <p:cNvPr id="9" name="Rectangle 8"/>
+          <p:cNvSpPr/>
+          <p:nvPr/>
+        </p:nvSpPr>
+        <p:spPr>
+          <a:xfrm>
+            <a:off x="731520" y="6400800"/>
+            <a:ext cx="10728655" cy="10972"/>
+          </a:xfrm>
+          <a:prstGeom prst="rect">
+            <a:avLst/>
+          </a:prstGeom>
+          <a:solidFill>
+            <a:srgbClr val="263042"/>
+          </a:solidFill>
+          <a:ln>
+            <a:solidFill>
+              <a:srgbClr val="263042"/>
+            </a:solidFill>
+          </a:ln>
+        </p:spPr>
+        <p:style>
+          <a:lnRef idx="1">
+            <a:schemeClr val="accent1"/>
+          </a:lnRef>
+          <a:fillRef idx="3">
+            <a:schemeClr val="accent1"/>
+          </a:fillRef>
+          <a:effectRef idx="2">
+            <a:schemeClr val="accent1"/>
+          </a:effectRef>
+          <a:fontRef idx="minor">
+            <a:schemeClr val="lt1"/>
+          </a:fontRef>
+        </p:style>
+        <p:txBody>
+          <a:bodyPr rtlCol="0" anchor="ctr"/>
+          <a:lstStyle/>
+          <a:p>
+            <a:pPr algn="ctr"/>
+          </a:p>
+        </p:txBody>
+      </p:sp>
+      <p:sp>
+        <p:nvSpPr>
+          <p:cNvPr id="10" name="TextBox 9"/>
+          <p:cNvSpPr txBox="1"/>
+          <p:nvPr/>
+        </p:nvSpPr>
+        <p:spPr>
+          <a:xfrm>
+            <a:off x="731520" y="6455664"/>
+            <a:ext cx="8229600" cy="256032"/>
+          </a:xfrm>
+          <a:prstGeom prst="rect">
+            <a:avLst/>
+          </a:prstGeom>
+          <a:noFill/>
+        </p:spPr>
+        <p:txBody>
+          <a:bodyPr wrap="none" lIns="0" tIns="0" rIns="0" bIns="0">
+            <a:spAutoFit/>
+          </a:bodyPr>
+          <a:lstStyle/>
+          <a:p>
+            <a:pPr>
+              <a:defRPr sz="850">
+                <a:solidFill>
+                  <a:srgbClr val="64748B"/>
+                </a:solidFill>
+              </a:defRPr>
+            </a:pPr>
+            <a:r>
+              <a:t>PROTOKOL HUD Manager  •  Комплекс CS2 турнирных трансляций  •  Версия v0.1.0</a:t>
+            </a:r>
+          </a:p>
+        </p:txBody>
+      </p:sp>
+      <p:sp>
+        <p:nvSpPr>
+          <p:cNvPr id="11" name="TextBox 10"/>
+          <p:cNvSpPr txBox="1"/>
+          <p:nvPr/>
+        </p:nvSpPr>
+        <p:spPr>
+          <a:xfrm>
+            <a:off x="9601200" y="6455664"/>
+            <a:ext cx="1858975" cy="256032"/>
+          </a:xfrm>
+          <a:prstGeom prst="rect">
+            <a:avLst/>
+          </a:prstGeom>
+          <a:noFill/>
+        </p:spPr>
+        <p:txBody>
+          <a:bodyPr wrap="none" lIns="0" tIns="0" rIns="0" bIns="0">
+            <a:spAutoFit/>
+          </a:bodyPr>
+          <a:lstStyle/>
+          <a:p>
+            <a:pPr algn="r">
+              <a:defRPr sz="850" b="1">
+                <a:solidFill>
+                  <a:srgbClr val="E5B869"/>
+                </a:solidFill>
+              </a:defRPr>
+            </a:pPr>
+            <a:r>
+              <a:t>12 / 13</a:t>
+            </a:r>
+          </a:p>
+        </p:txBody>
+      </p:sp>
+    </p:spTree>
+  </p:cSld>
+  <p:clrMapOvr>
+    <a:masterClrMapping/>
+  </p:clrMapOvr>
+</p:sld>
+</file>
+
+<file path=ppt/slides/slide13.xml><?xml version="1.0" encoding="utf-8"?>
+<p:sld xmlns:a="http://schemas.openxmlformats.org/drawingml/2006/main" xmlns:p="http://schemas.openxmlformats.org/presentationml/2006/main" xmlns:r="http://schemas.openxmlformats.org/officeDocument/2006/relationships">
+  <p:cSld>
+    <p:bg>
+      <p:bgPr>
+        <a:solidFill>
+          <a:srgbClr val="0B0E14"/>
+        </a:solidFill>
+        <a:effectLst/>
+      </p:bgPr>
+    </p:bg>
+    <p:spTree>
+      <p:nvGrpSpPr>
+        <p:cNvPr id="1" name=""/>
+        <p:cNvGrpSpPr/>
+        <p:nvPr/>
+      </p:nvGrpSpPr>
+      <p:grpSpPr/>
+      <p:sp>
+        <p:nvSpPr>
+          <p:cNvPr id="2" name="TextBox 1"/>
+          <p:cNvSpPr txBox="1"/>
+          <p:nvPr/>
+        </p:nvSpPr>
+        <p:spPr>
+          <a:xfrm>
+            <a:off x="731520" y="365760"/>
+            <a:ext cx="10728655" cy="256032"/>
+          </a:xfrm>
+          <a:prstGeom prst="rect">
+            <a:avLst/>
+          </a:prstGeom>
+          <a:noFill/>
+        </p:spPr>
+        <p:txBody>
+          <a:bodyPr wrap="square" lIns="0" tIns="0" rIns="0" bIns="0">
+            <a:spAutoFit/>
+          </a:bodyPr>
+          <a:lstStyle/>
+          <a:p>
+            <a:pPr>
+              <a:defRPr sz="950" b="1">
+                <a:solidFill>
+                  <a:srgbClr val="E5B869"/>
+                </a:solidFill>
+              </a:defRPr>
+            </a:pPr>
+            <a:r>
+              <a:t>НАДЁЖНОСТЬ ЭФИРА  •  OPERATIONS &amp; DIAGNOSTICS</a:t>
+            </a:r>
+          </a:p>
+        </p:txBody>
+      </p:sp>
+      <p:sp>
+        <p:nvSpPr>
+          <p:cNvPr id="3" name="TextBox 2"/>
+          <p:cNvSpPr txBox="1"/>
+          <p:nvPr/>
+        </p:nvSpPr>
+        <p:spPr>
+          <a:xfrm>
+            <a:off x="731520" y="621792"/>
+            <a:ext cx="10728655" cy="502920"/>
+          </a:xfrm>
+          <a:prstGeom prst="rect">
+            <a:avLst/>
+          </a:prstGeom>
+          <a:noFill/>
+        </p:spPr>
+        <p:txBody>
+          <a:bodyPr wrap="square" lIns="0" tIns="0" rIns="0" bIns="0">
+            <a:spAutoFit/>
+          </a:bodyPr>
+          <a:lstStyle/>
+          <a:p>
+            <a:pPr>
+              <a:defRPr sz="2100" b="1">
+                <a:solidFill>
+                  <a:srgbClr val="F8FAFC"/>
+                </a:solidFill>
+              </a:defRPr>
+            </a:pPr>
+            <a:r>
+              <a:t>Веб-камеры игроков, регламент эфира и диагностика</a:t>
+            </a:r>
+          </a:p>
+        </p:txBody>
+      </p:sp>
+      <p:sp>
+        <p:nvSpPr>
+          <p:cNvPr id="4" name="TextBox 3"/>
+          <p:cNvSpPr txBox="1"/>
+          <p:nvPr/>
+        </p:nvSpPr>
+        <p:spPr>
+          <a:xfrm>
+            <a:off x="731520" y="1133856"/>
+            <a:ext cx="10728655" cy="347472"/>
+          </a:xfrm>
+          <a:prstGeom prst="rect">
+            <a:avLst/>
+          </a:prstGeom>
+          <a:noFill/>
+        </p:spPr>
+        <p:txBody>
+          <a:bodyPr wrap="square" lIns="0" tIns="0" rIns="0" bIns="0">
+            <a:spAutoFit/>
+          </a:bodyPr>
+          <a:lstStyle/>
+          <a:p>
+            <a:pPr>
+              <a:defRPr sz="1100">
+                <a:solidFill>
+                  <a:srgbClr val="94A3B8"/>
+                </a:solidFill>
+              </a:defRPr>
+            </a:pPr>
+            <a:r>
+              <a:t>Привязка SteamID64 к VDO.Ninja, фолбэк на 2D-аватары агентов, чек-лист оператора и устранение сбоев</a:t>
+            </a:r>
+          </a:p>
+        </p:txBody>
+      </p:sp>
+      <p:sp>
+        <p:nvSpPr>
+          <p:cNvPr id="5" name="Rounded Rectangle 4"/>
+          <p:cNvSpPr/>
+          <p:nvPr/>
+        </p:nvSpPr>
+        <p:spPr>
+          <a:xfrm>
+            <a:off x="731520" y="1600200"/>
+            <a:ext cx="5212080" cy="4480560"/>
+          </a:xfrm>
+          <a:prstGeom prst="roundRect">
+            <a:avLst/>
+          </a:prstGeom>
+          <a:solidFill>
+            <a:srgbClr val="131822"/>
+          </a:solidFill>
+          <a:ln w="12700">
+            <a:solidFill>
+              <a:srgbClr val="263042"/>
+            </a:solidFill>
+          </a:ln>
+        </p:spPr>
+        <p:style>
+          <a:lnRef idx="1">
+            <a:schemeClr val="accent1"/>
+          </a:lnRef>
+          <a:fillRef idx="3">
+            <a:schemeClr val="accent1"/>
+          </a:fillRef>
+          <a:effectRef idx="2">
+            <a:schemeClr val="accent1"/>
+          </a:effectRef>
+          <a:fontRef idx="minor">
+            <a:schemeClr val="lt1"/>
+          </a:fontRef>
+        </p:style>
+        <p:txBody>
+          <a:bodyPr rtlCol="0" anchor="ctr"/>
+          <a:lstStyle/>
+          <a:p>
+            <a:pPr algn="ctr"/>
+          </a:p>
+        </p:txBody>
+      </p:sp>
+      <p:sp>
+        <p:nvSpPr>
+          <p:cNvPr id="6" name="TextBox 5"/>
+          <p:cNvSpPr txBox="1"/>
+          <p:nvPr/>
+        </p:nvSpPr>
+        <p:spPr>
+          <a:xfrm>
+            <a:off x="914400" y="1783080"/>
+            <a:ext cx="4846320" cy="4114800"/>
+          </a:xfrm>
+          <a:prstGeom prst="rect">
+            <a:avLst/>
+          </a:prstGeom>
+          <a:noFill/>
+        </p:spPr>
+        <p:txBody>
+          <a:bodyPr wrap="square">
+            <a:spAutoFit/>
+          </a:bodyPr>
+          <a:lstStyle/>
+          <a:p>
+            <a:pPr>
+              <a:defRPr sz="1100" b="1">
+                <a:solidFill>
+                  <a:srgbClr val="E5B869"/>
+                </a:solidFill>
+              </a:defRPr>
+            </a:pPr>
+            <a:r>
+              <a:t>СИСТЕМА ДИНАМИЧЕСКОГО ФОКУСА ВЕБ-КАМЕР</a:t>
+            </a:r>
+          </a:p>
+          <a:p>
+            <a:pPr>
+              <a:defRPr sz="950" b="1">
+                <a:solidFill>
+                  <a:srgbClr val="E5B869"/>
+                </a:solidFill>
+              </a:defRPr>
+            </a:pPr>
+            <a:r>
+              <a:t>• Привязка по 17-значному SteamID64: </a:t>
+            </a:r>
+          </a:p>
+          <a:p>
+            <a:pPr>
+              <a:defRPr sz="850">
+                <a:solidFill>
+                  <a:srgbClr val="CBD5E1"/>
+                </a:solidFill>
+              </a:defRPr>
+            </a:pPr>
+            <a:r>
+              <a:t>Страница «Веб-камеры»: каждый SteamID связывается с видеопотоком. При спектаторстве в CS2 видео монтируется в карточку автоматически.</a:t>
+            </a:r>
+          </a:p>
+          <a:p>
+            <a:pPr>
+              <a:defRPr sz="950" b="1">
+                <a:solidFill>
+                  <a:srgbClr val="E5B869"/>
+                </a:solidFill>
+              </a:defRPr>
+            </a:pPr>
+            <a:r>
+              <a:t>• Кэширование DOM без мерцания: </a:t>
+            </a:r>
+          </a:p>
+          <a:p>
+            <a:pPr>
+              <a:defRPr sz="850">
+                <a:solidFill>
+                  <a:srgbClr val="CBD5E1"/>
+                </a:solidFill>
+              </a:defRPr>
+            </a:pPr>
+            <a:r>
+              <a:t>Пока спектатор наблюдает за одним игроком, тики GSI не пересоздают DOM-элемент &lt;video&gt;/&lt;iframe&gt; (cameraSlots) и не сбрасывают видеопоток.</a:t>
+            </a:r>
+          </a:p>
+          <a:p>
+            <a:pPr>
+              <a:defRPr sz="950" b="1">
+                <a:solidFill>
+                  <a:srgbClr val="E5B869"/>
+                </a:solidFill>
+              </a:defRPr>
+            </a:pPr>
+            <a:r>
+              <a:t>• Поддержка VDO.Ninja и Direct Video: </a:t>
+            </a:r>
+          </a:p>
+          <a:p>
+            <a:pPr>
+              <a:defRPr sz="850">
+                <a:solidFill>
+                  <a:srgbClr val="CBD5E1"/>
+                </a:solidFill>
+              </a:defRPr>
+            </a:pPr>
+            <a:r>
+              <a:t>Формат iframe: https://vdo.ninja/?view=...&amp;cleanoutput&amp;transparent. Параметр &amp;muted выставляется ядром принудительно для защиты от эха.</a:t>
+            </a:r>
+          </a:p>
+          <a:p>
+            <a:pPr>
+              <a:defRPr sz="950" b="1">
+                <a:solidFill>
+                  <a:srgbClr val="E5B869"/>
+                </a:solidFill>
+              </a:defRPr>
+            </a:pPr>
+            <a:r>
+              <a:t>• Штатный Dual-Mode фолбэк на агента: </a:t>
+            </a:r>
+          </a:p>
+          <a:p>
+            <a:pPr>
+              <a:defRPr sz="850">
+                <a:solidFill>
+                  <a:srgbClr val="CBD5E1"/>
+                </a:solidFill>
+              </a:defRPr>
+            </a:pPr>
+            <a:r>
+              <a:t>При отсутствии камеры отображается статический 2D-бодишот агента CS2 (CT/T). Параметр ?cam=live делает вырез прозрачным под камеру OBS.</a:t>
+            </a:r>
+          </a:p>
+          <a:p>
+            <a:pPr>
+              <a:defRPr sz="950" b="1">
+                <a:solidFill>
+                  <a:srgbClr val="E5B869"/>
+                </a:solidFill>
+              </a:defRPr>
+            </a:pPr>
+            <a:r>
+              <a:t>• Встроенный предпросмотр перед матчем: </a:t>
+            </a:r>
+          </a:p>
+          <a:p>
+            <a:pPr>
+              <a:defRPr sz="850">
+                <a:solidFill>
+                  <a:srgbClr val="CBD5E1"/>
+                </a:solidFill>
+              </a:defRPr>
+            </a:pPr>
+            <a:r>
+              <a:t>Оператор трансляции может проверить видео каждого игрока в модальном плеере менеджера до выхода в эфир.</a:t>
+            </a:r>
+          </a:p>
+        </p:txBody>
+      </p:sp>
+      <p:sp>
+        <p:nvSpPr>
+          <p:cNvPr id="7" name="Rounded Rectangle 6"/>
+          <p:cNvSpPr/>
+          <p:nvPr/>
+        </p:nvSpPr>
+        <p:spPr>
+          <a:xfrm>
+            <a:off x="6217920" y="1600200"/>
+            <a:ext cx="5212080" cy="4480560"/>
+          </a:xfrm>
+          <a:prstGeom prst="roundRect">
+            <a:avLst/>
+          </a:prstGeom>
+          <a:solidFill>
+            <a:srgbClr val="131822"/>
+          </a:solidFill>
+          <a:ln w="12700">
+            <a:solidFill>
+              <a:srgbClr val="263042"/>
+            </a:solidFill>
+          </a:ln>
+        </p:spPr>
+        <p:style>
+          <a:lnRef idx="1">
+            <a:schemeClr val="accent1"/>
+          </a:lnRef>
+          <a:fillRef idx="3">
+            <a:schemeClr val="accent1"/>
+          </a:fillRef>
+          <a:effectRef idx="2">
+            <a:schemeClr val="accent1"/>
+          </a:effectRef>
+          <a:fontRef idx="minor">
+            <a:schemeClr val="lt1"/>
+          </a:fontRef>
+        </p:style>
+        <p:txBody>
+          <a:bodyPr rtlCol="0" anchor="ctr"/>
+          <a:lstStyle/>
+          <a:p>
+            <a:pPr algn="ctr"/>
+          </a:p>
+        </p:txBody>
+      </p:sp>
+      <p:sp>
+        <p:nvSpPr>
+          <p:cNvPr id="8" name="TextBox 7"/>
+          <p:cNvSpPr txBox="1"/>
+          <p:nvPr/>
+        </p:nvSpPr>
+        <p:spPr>
+          <a:xfrm>
+            <a:off x="6400800" y="1783080"/>
+            <a:ext cx="4846320" cy="4114800"/>
+          </a:xfrm>
+          <a:prstGeom prst="rect">
+            <a:avLst/>
+          </a:prstGeom>
+          <a:noFill/>
+        </p:spPr>
+        <p:txBody>
+          <a:bodyPr wrap="square">
+            <a:spAutoFit/>
+          </a:bodyPr>
+          <a:lstStyle/>
+          <a:p>
+            <a:pPr>
+              <a:defRPr sz="1100" b="1">
+                <a:solidFill>
+                  <a:srgbClr val="F59E0B"/>
+                </a:solidFill>
+              </a:defRPr>
+            </a:pPr>
+            <a:r>
+              <a:t>ЧЕК-ЛИСТ ОПЕРАТОРА И УСТРАНЕНИЕ НЕПОЛАДОК</a:t>
+            </a:r>
+          </a:p>
+          <a:p>
+            <a:pPr>
+              <a:defRPr sz="950" b="1">
+                <a:solidFill>
+                  <a:srgbClr val="F59E0B"/>
+                </a:solidFill>
+              </a:defRPr>
+            </a:pPr>
+            <a:r>
+              <a:t>• Порядок запуска (Launch Ordering): </a:t>
+            </a:r>
+          </a:p>
+          <a:p>
+            <a:pPr>
+              <a:defRPr sz="850">
+                <a:solidFill>
+                  <a:srgbClr val="CBD5E1"/>
+                </a:solidFill>
+              </a:defRPr>
+            </a:pPr>
+            <a:r>
+              <a:t>1. Запуск PROTOKOL Manager (:1349) → 2. Запуск OBS Studio → 3. Холодный запуск CS2 (обсервер) → 4. Вход на сервер / GOTV.</a:t>
+            </a:r>
+          </a:p>
+          <a:p>
+            <a:pPr>
+              <a:defRPr sz="950" b="1">
+                <a:solidFill>
+                  <a:srgbClr val="F59E0B"/>
+                </a:solidFill>
+              </a:defRPr>
+            </a:pPr>
+            <a:r>
+              <a:t>• Видно только 1 игрока, радар пустой: </a:t>
+            </a:r>
+          </a:p>
+          <a:p>
+            <a:pPr>
+              <a:defRPr sz="850">
+                <a:solidFill>
+                  <a:srgbClr val="CBD5E1"/>
+                </a:solidFill>
+              </a:defRPr>
+            </a:pPr>
+            <a:r>
+              <a:t>CS2 запущена на обычном клиентском POV-аккаунте. Перейдите в режим наблюдателя (spectator) или GOTV.</a:t>
+            </a:r>
+          </a:p>
+          <a:p>
+            <a:pPr>
+              <a:defRPr sz="950" b="1">
+                <a:solidFill>
+                  <a:srgbClr val="F59E0B"/>
+                </a:solidFill>
+              </a:defRPr>
+            </a:pPr>
+            <a:r>
+              <a:t>• Индикатор Live неактивен, нет данных: </a:t>
+            </a:r>
+          </a:p>
+          <a:p>
+            <a:pPr>
+              <a:defRPr sz="850">
+                <a:solidFill>
+                  <a:srgbClr val="CBD5E1"/>
+                </a:solidFill>
+              </a:defRPr>
+            </a:pPr>
+            <a:r>
+              <a:t>CS2 не перезапускалась после создания cfg; cfg в старой csgo\cfg\; не совпадает auth.token; порт 1349 занят (netstat -ano).</a:t>
+            </a:r>
+          </a:p>
+          <a:p>
+            <a:pPr>
+              <a:defRPr sz="950" b="1">
+                <a:solidFill>
+                  <a:srgbClr val="F59E0B"/>
+                </a:solidFill>
+              </a:defRPr>
+            </a:pPr>
+            <a:r>
+              <a:t>• Чёрный экран оверлея в OBS Studio: </a:t>
+            </a:r>
+          </a:p>
+          <a:p>
+            <a:pPr>
+              <a:defRPr sz="850">
+                <a:solidFill>
+                  <a:srgbClr val="CBD5E1"/>
+                </a:solidFill>
+              </a:defRPr>
+            </a:pPr>
+            <a:r>
+              <a:t>Проверьте URL: /overlay/&lt;name&gt;/index.html (overlay в ед. числе), проверьте файлы в %APPDATA%, обновите кэш Browser Source.</a:t>
+            </a:r>
+          </a:p>
+          <a:p>
+            <a:pPr>
+              <a:defRPr sz="950" b="1">
+                <a:solidFill>
+                  <a:srgbClr val="F59E0B"/>
+                </a:solidFill>
+              </a:defRPr>
+            </a:pPr>
+            <a:r>
+              <a:t>• Веб-камера игрока не отображается: </a:t>
+            </a:r>
+          </a:p>
+          <a:p>
+            <a:pPr>
+              <a:defRPr sz="850">
+                <a:solidFill>
+                  <a:srgbClr val="CBD5E1"/>
+                </a:solidFill>
+              </a:defRPr>
+            </a:pPr>
+            <a:r>
+              <a:t>Проверьте SteamID (ровно 17 цифр), проверьте отсутствие логина/пароля в URL, выберите тип «iframe / VDO.Ninja» для ссылок VDO.</a:t>
+            </a:r>
+          </a:p>
+        </p:txBody>
+      </p:sp>
+      <p:sp>
+        <p:nvSpPr>
+          <p:cNvPr id="9" name="Rectangle 8"/>
+          <p:cNvSpPr/>
+          <p:nvPr/>
+        </p:nvSpPr>
+        <p:spPr>
+          <a:xfrm>
+            <a:off x="731520" y="6400800"/>
+            <a:ext cx="10728655" cy="10972"/>
+          </a:xfrm>
+          <a:prstGeom prst="rect">
+            <a:avLst/>
+          </a:prstGeom>
+          <a:solidFill>
+            <a:srgbClr val="263042"/>
+          </a:solidFill>
+          <a:ln>
+            <a:solidFill>
+              <a:srgbClr val="263042"/>
+            </a:solidFill>
+          </a:ln>
+        </p:spPr>
+        <p:style>
+          <a:lnRef idx="1">
+            <a:schemeClr val="accent1"/>
+          </a:lnRef>
+          <a:fillRef idx="3">
+            <a:schemeClr val="accent1"/>
+          </a:fillRef>
+          <a:effectRef idx="2">
+            <a:schemeClr val="accent1"/>
+          </a:effectRef>
+          <a:fontRef idx="minor">
+            <a:schemeClr val="lt1"/>
+          </a:fontRef>
+        </p:style>
+        <p:txBody>
+          <a:bodyPr rtlCol="0" anchor="ctr"/>
+          <a:lstStyle/>
+          <a:p>
+            <a:pPr algn="ctr"/>
+          </a:p>
+        </p:txBody>
+      </p:sp>
+      <p:sp>
+        <p:nvSpPr>
+          <p:cNvPr id="10" name="TextBox 9"/>
+          <p:cNvSpPr txBox="1"/>
+          <p:nvPr/>
+        </p:nvSpPr>
+        <p:spPr>
+          <a:xfrm>
+            <a:off x="731520" y="6455664"/>
+            <a:ext cx="8229600" cy="256032"/>
+          </a:xfrm>
+          <a:prstGeom prst="rect">
+            <a:avLst/>
+          </a:prstGeom>
+          <a:noFill/>
+        </p:spPr>
+        <p:txBody>
+          <a:bodyPr wrap="none" lIns="0" tIns="0" rIns="0" bIns="0">
+            <a:spAutoFit/>
+          </a:bodyPr>
+          <a:lstStyle/>
+          <a:p>
+            <a:pPr>
+              <a:defRPr sz="850">
+                <a:solidFill>
+                  <a:srgbClr val="64748B"/>
+                </a:solidFill>
+              </a:defRPr>
+            </a:pPr>
+            <a:r>
+              <a:t>PROTOKOL HUD Manager  •  Комплекс CS2 турнирных трансляций  •  Версия v0.1.0</a:t>
+            </a:r>
+          </a:p>
+        </p:txBody>
+      </p:sp>
+      <p:sp>
+        <p:nvSpPr>
+          <p:cNvPr id="11" name="TextBox 10"/>
+          <p:cNvSpPr txBox="1"/>
+          <p:nvPr/>
+        </p:nvSpPr>
+        <p:spPr>
+          <a:xfrm>
+            <a:off x="9601200" y="6455664"/>
+            <a:ext cx="1858975" cy="256032"/>
+          </a:xfrm>
+          <a:prstGeom prst="rect">
+            <a:avLst/>
+          </a:prstGeom>
+          <a:noFill/>
+        </p:spPr>
+        <p:txBody>
+          <a:bodyPr wrap="none" lIns="0" tIns="0" rIns="0" bIns="0">
+            <a:spAutoFit/>
+          </a:bodyPr>
+          <a:lstStyle/>
+          <a:p>
+            <a:pPr algn="r">
+              <a:defRPr sz="850" b="1">
+                <a:solidFill>
+                  <a:srgbClr val="E5B869"/>
+                </a:solidFill>
+              </a:defRPr>
+            </a:pPr>
+            <a:r>
+              <a:t>13 / 13</a:t>
             </a:r>
           </a:p>
         </p:txBody>
@@ -6650,7 +8929,7 @@
               </a:defRPr>
             </a:pPr>
             <a:r>
-              <a:t>02 / 10</a:t>
+              <a:t>02 / 13</a:t>
             </a:r>
           </a:p>
         </p:txBody>
@@ -6833,7 +9112,7 @@
       </p:sp>
       <p:pic>
         <p:nvPicPr>
-          <p:cNvPr id="6" name="Picture 5" descr="fennec-cyber-video.png"/>
+          <p:cNvPr id="6" name="Picture 5" descr="fennec-cyber-agent-transparent.png"/>
           <p:cNvPicPr>
             <a:picLocks noChangeAspect="1"/>
           </p:cNvPicPr>
@@ -6885,7 +9164,7 @@
               </a:defRPr>
             </a:pPr>
             <a:r>
-              <a:t>Демонстрация с тестовым паттерном видеопотока (1920×1080). В продакшне окно занимает живая камера игрока.</a:t>
+              <a:t>Оверлей 1080p: прозрачный радар, статический 2D-фолбэк агента CT/T (не вебкамера).</a:t>
             </a:r>
           </a:p>
         </p:txBody>
@@ -7035,7 +9314,7 @@
               </a:defRPr>
             </a:pPr>
             <a:r>
-              <a:t>Встроенная скошенная 16:9 окантовка с бейджем «LIVE CAM» над плашкой активного игрока.</a:t>
+              <a:t>Встроенная скошенная 16:9 окантовка с бейджем «LIVE CAM». При отсутствии камеры отображается статический агент.</a:t>
             </a:r>
           </a:p>
           <a:p>
@@ -7064,7 +9343,7 @@
               </a:defRPr>
             </a:pPr>
             <a:r>
-              <a:t>Чистые неоновые контуры карты CS2 без громоздкого черного фонового квадрата.</a:t>
+              <a:t>Чистые неоновые контуры карты CS2 без громоздкого черного фонового квадрата (альфа-прозрачность).</a:t>
             </a:r>
           </a:p>
           <a:p>
@@ -7208,7 +9487,7 @@
               </a:defRPr>
             </a:pPr>
             <a:r>
-              <a:t>03 / 10</a:t>
+              <a:t>03 / 13</a:t>
             </a:r>
           </a:p>
         </p:txBody>
@@ -7391,7 +9670,7 @@
       </p:sp>
       <p:pic>
         <p:nvPicPr>
-          <p:cNvPr id="6" name="Picture 5" descr="fennec-broadcast-video.png"/>
+          <p:cNvPr id="6" name="Picture 5" descr="fennec-broadcast-agent-transparent.png"/>
           <p:cNvPicPr>
             <a:picLocks noChangeAspect="1"/>
           </p:cNvPicPr>
@@ -7443,7 +9722,7 @@
               </a:defRPr>
             </a:pPr>
             <a:r>
-              <a:t>Эталонный лейаут пака: центрированная камера, разряженная верстка, нулевой клиппинг.</a:t>
+              <a:t>Студийный оверлей: прозрачная миникарта, статический агент CT/T в фокусе (не вебкамера).</a:t>
             </a:r>
           </a:p>
         </p:txBody>
@@ -7766,7 +10045,7 @@
               </a:defRPr>
             </a:pPr>
             <a:r>
-              <a:t>04 / 10</a:t>
+              <a:t>04 / 13</a:t>
             </a:r>
           </a:p>
         </p:txBody>
@@ -7949,7 +10228,7 @@
       </p:sp>
       <p:pic>
         <p:nvPicPr>
-          <p:cNvPr id="6" name="Picture 5" descr="championship-names-fixed.png"/>
+          <p:cNvPr id="6" name="Picture 5" descr="fennec-championship-agent-transparent.png"/>
           <p:cNvPicPr>
             <a:picLocks noChangeAspect="1"/>
           </p:cNvPicPr>
@@ -8001,7 +10280,7 @@
               </a:defRPr>
             </a:pPr>
             <a:r>
-              <a:t>Актуальный рендер: подтвержденная однострочная посадка длинных никнеймов (10 игроков).</a:t>
+              <a:t>Золотой HUD: прозрачный радар, однострочные ростеры, статический агент CT/T (не вебкамера).</a:t>
             </a:r>
           </a:p>
         </p:txBody>
@@ -8324,7 +10603,7 @@
               </a:defRPr>
             </a:pPr>
             <a:r>
-              <a:t>05 / 10</a:t>
+              <a:t>05 / 13</a:t>
             </a:r>
           </a:p>
         </p:txBody>
@@ -8853,7 +11132,7 @@
               </a:defRPr>
             </a:pPr>
             <a:r>
-              <a:t>06 / 10</a:t>
+              <a:t>06 / 13</a:t>
             </a:r>
           </a:p>
         </p:txBody>
@@ -9382,7 +11661,7 @@
               </a:defRPr>
             </a:pPr>
             <a:r>
-              <a:t>07 / 10</a:t>
+              <a:t>07 / 13</a:t>
             </a:r>
           </a:p>
         </p:txBody>
@@ -10048,7 +12327,7 @@
               </a:defRPr>
             </a:pPr>
             <a:r>
-              <a:t>08 / 10</a:t>
+              <a:t>08 / 13</a:t>
             </a:r>
           </a:p>
         </p:txBody>
@@ -10646,7 +12925,7 @@
               </a:defRPr>
             </a:pPr>
             <a:r>
-              <a:t>09 / 10</a:t>
+              <a:t>09 / 13</a:t>
             </a:r>
           </a:p>
         </p:txBody>

</xml_diff>

<commit_message>
PPTX final: normAutofit fit pass eliminates text overflow on dense slides (verified 0 frames over)
</commit_message>
<xml_diff>
--- a/docs/presentation/protokol-presentation.pptx
+++ b/docs/presentation/protokol-presentation.pptx
@@ -4500,6 +4500,7 @@
               </a:defRPr>
             </a:pPr>
             <a:r>
+              <a:rPr/>
               <a:t>PROTOKOL HUD Manager</a:t>
             </a:r>
           </a:p>
@@ -4535,10 +4536,12 @@
               </a:defRPr>
             </a:pPr>
             <a:r>
+              <a:rPr/>
               <a:t>Автономный нативный комбайн управления трансляциями CS2:</a:t>
             </a:r>
             <a:br/>
             <a:r>
+              <a:rPr/>
               <a:t>ядро Tauri v2 + Rust, 3 независимых стиля HUD, SQLite WAL и интеграция веб-камер игроков</a:t>
             </a:r>
           </a:p>
@@ -4619,6 +4622,7 @@
               </a:defRPr>
             </a:pPr>
             <a:r>
+              <a:rPr/>
               <a:t>ЯДРО СИСТЕМЫ</a:t>
             </a:r>
           </a:p>
@@ -4631,6 +4635,7 @@
               </a:defRPr>
             </a:pPr>
             <a:r>
+              <a:rPr/>
               <a:t>Rust Axum + Tauri v2</a:t>
             </a:r>
           </a:p>
@@ -4711,6 +4716,7 @@
               </a:defRPr>
             </a:pPr>
             <a:r>
+              <a:rPr/>
               <a:t>БАЗА ДАННЫХ</a:t>
             </a:r>
           </a:p>
@@ -4723,6 +4729,7 @@
               </a:defRPr>
             </a:pPr>
             <a:r>
+              <a:rPr/>
               <a:t>SQLite WAL (локально)</a:t>
             </a:r>
           </a:p>
@@ -4803,6 +4810,7 @@
               </a:defRPr>
             </a:pPr>
             <a:r>
+              <a:rPr/>
               <a:t>ТЕЛЕМЕТРИЯ CS2</a:t>
             </a:r>
           </a:p>
@@ -4815,6 +4823,7 @@
               </a:defRPr>
             </a:pPr>
             <a:r>
+              <a:rPr/>
               <a:t>Realtime WebSocket</a:t>
             </a:r>
           </a:p>
@@ -4895,6 +4904,7 @@
               </a:defRPr>
             </a:pPr>
             <a:r>
+              <a:rPr/>
               <a:t>ФОРМ-ФАКТОР</a:t>
             </a:r>
           </a:p>
@@ -4907,6 +4917,7 @@
               </a:defRPr>
             </a:pPr>
             <a:r>
+              <a:rPr/>
               <a:t>Tauri Desktop App</a:t>
             </a:r>
           </a:p>
@@ -5118,6 +5129,7 @@
               </a:defRPr>
             </a:pPr>
             <a:r>
+              <a:rPr/>
               <a:t>Готовность к внедрению и вектор технологического развития</a:t>
             </a:r>
           </a:p>
@@ -5233,6 +5245,7 @@
               </a:defRPr>
             </a:pPr>
             <a:r>
+              <a:rPr/>
               <a:t>КЛЮЧЕВЫЕ ВЫГОДЫ ДЛЯ ТУРНИРА</a:t>
             </a:r>
           </a:p>
@@ -5245,6 +5258,7 @@
               </a:defRPr>
             </a:pPr>
             <a:r>
+              <a:rPr/>
               <a:t>★ Снижение риска сбоев эфира: </a:t>
             </a:r>
           </a:p>
@@ -5257,6 +5271,7 @@
               </a:defRPr>
             </a:pPr>
             <a:r>
+              <a:rPr/>
               <a:t>Отказ от внешнего рантайма Node.js и тяжелых промежуточных сервисов в пользу скомпилированного нативного бэкенда.</a:t>
             </a:r>
           </a:p>
@@ -5269,6 +5284,7 @@
               </a:defRPr>
             </a:pPr>
             <a:r>
+              <a:rPr/>
               <a:t>★ Премиальная картинка трансляции: </a:t>
             </a:r>
           </a:p>
@@ -5281,6 +5297,7 @@
               </a:defRPr>
             </a:pPr>
             <a:r>
+              <a:rPr/>
               <a:t>Три готовых самобытных стиля оверлеев (Cyber, Broadcast, Championship) закрывают потребности любых форматов — от региональных квалификаций до гранд-финалов.</a:t>
             </a:r>
           </a:p>
@@ -5293,6 +5310,7 @@
               </a:defRPr>
             </a:pPr>
             <a:r>
+              <a:rPr/>
               <a:t>★ Быстрый старт вещания: </a:t>
             </a:r>
           </a:p>
@@ -5305,6 +5323,7 @@
               </a:defRPr>
             </a:pPr>
             <a:r>
+              <a:rPr/>
               <a:t>Автогенерация GSI конфига и единая кнопка экспорта OBS Browser Source минимизируют человеческий фактор при настройке.</a:t>
             </a:r>
           </a:p>
@@ -5317,6 +5336,7 @@
               </a:defRPr>
             </a:pPr>
             <a:r>
+              <a:rPr/>
               <a:t>★ Легкая замена графических материалов: </a:t>
             </a:r>
           </a:p>
@@ -5329,6 +5349,7 @@
               </a:defRPr>
             </a:pPr>
             <a:r>
+              <a:rPr/>
               <a:t>Модульная структура позволяет оперативно брендировать HUD под спонсоров и партнеров турнира.</a:t>
             </a:r>
           </a:p>
@@ -5409,6 +5430,7 @@
               </a:defRPr>
             </a:pPr>
             <a:r>
+              <a:rPr/>
               <a:t>ПЛАН РАЗВИТИЯ СИСТЕМЫ (ROADMAP v0.2+)</a:t>
             </a:r>
           </a:p>
@@ -5421,6 +5443,7 @@
               </a:defRPr>
             </a:pPr>
             <a:r>
+              <a:rPr/>
               <a:t>➔ WebRTC WebCam Hub: </a:t>
             </a:r>
           </a:p>
@@ -5433,6 +5456,7 @@
               </a:defRPr>
             </a:pPr>
             <a:r>
+              <a:rPr/>
               <a:t>Встроенный сервер WebRTC в ядре Axum для прямого подключения мобильных телефонов игроков как вебкамер по QR-коду без сторонних платформ.</a:t>
             </a:r>
           </a:p>
@@ -5445,6 +5469,7 @@
               </a:defRPr>
             </a:pPr>
             <a:r>
+              <a:rPr/>
               <a:t>➔ Интерактивный Theme Customizer: </a:t>
             </a:r>
           </a:p>
@@ -5457,6 +5482,7 @@
               </a:defRPr>
             </a:pPr>
             <a:r>
+              <a:rPr/>
               <a:t>Возможность кастомизировать градиенты и фирменные цвета команд прямо из графического интерфейса менеджера без правки CSS.</a:t>
             </a:r>
           </a:p>
@@ -5469,6 +5495,7 @@
               </a:defRPr>
             </a:pPr>
             <a:r>
+              <a:rPr/>
               <a:t>➔ Интеграция HLTV / Liquipedia API: </a:t>
             </a:r>
           </a:p>
@@ -5481,6 +5508,7 @@
               </a:defRPr>
             </a:pPr>
             <a:r>
+              <a:rPr/>
               <a:t>Автоматическая подгрузка актуальных аватаров игроков, истории встреч и турнирной сетки по коду матча.</a:t>
             </a:r>
           </a:p>
@@ -5493,6 +5521,7 @@
               </a:defRPr>
             </a:pPr>
             <a:r>
+              <a:rPr/>
               <a:t>➔ Событийный аудио-движок оверлея: </a:t>
             </a:r>
           </a:p>
@@ -5505,6 +5534,7 @@
               </a:defRPr>
             </a:pPr>
             <a:r>
+              <a:rPr/>
               <a:t>Синхронное воспроизведение саунд-эффектов (таймер C4, анонс Ace, победный гонг) напрямую в аудиодорожку браузерного источника OBS.</a:t>
             </a:r>
           </a:p>
@@ -5716,6 +5746,7 @@
               </a:defRPr>
             </a:pPr>
             <a:r>
+              <a:rPr/>
               <a:t>Установка, запуск и интеграция CS2 GSI</a:t>
             </a:r>
           </a:p>
@@ -5820,6 +5851,7 @@
         <p:txBody>
           <a:bodyPr wrap="square">
             <a:spAutoFit/>
+            <a:normAutofit fontScale="89000" lnSpcReduction="10000"/>
           </a:bodyPr>
           <a:lstStyle/>
           <a:p>
@@ -5831,6 +5863,7 @@
               </a:defRPr>
             </a:pPr>
             <a:r>
+              <a:rPr/>
               <a:t>1. ЗАПУСК И ПУТИ ДАННЫХ</a:t>
             </a:r>
           </a:p>
@@ -5843,6 +5876,7 @@
               </a:defRPr>
             </a:pPr>
             <a:r>
+              <a:rPr/>
               <a:t>• Бинарник: </a:t>
             </a:r>
           </a:p>
@@ -5855,6 +5889,7 @@
               </a:defRPr>
             </a:pPr>
             <a:r>
+              <a:rPr/>
               <a:t>Запуск protokol-hud-manager.exe (18.8 МБ). SmartScreen: «Подробнее» → «Выполнить в любом случае».</a:t>
             </a:r>
           </a:p>
@@ -5867,6 +5902,7 @@
               </a:defRPr>
             </a:pPr>
             <a:r>
+              <a:rPr/>
               <a:t>• База данных SQLite WAL: </a:t>
             </a:r>
           </a:p>
@@ -5879,6 +5915,7 @@
               </a:defRPr>
             </a:pPr>
             <a:r>
+              <a:rPr/>
               <a:t>Автосоздание рабочей БД %APPDATA%\PROTOKOL HUD\protokol.db со всеми таблицами при старте.</a:t>
             </a:r>
           </a:p>
@@ -5891,6 +5928,7 @@
               </a:defRPr>
             </a:pPr>
             <a:r>
+              <a:rPr/>
               <a:t>• Сетевой порт ядра :1349: </a:t>
             </a:r>
           </a:p>
@@ -5903,6 +5941,7 @@
               </a:defRPr>
             </a:pPr>
             <a:r>
+              <a:rPr/>
               <a:t>HTTP/WebSocket сервер слушает http://127.0.0.1:1349 с автоперебором fallback-портов до :1359.</a:t>
             </a:r>
           </a:p>
@@ -5915,6 +5954,7 @@
               </a:defRPr>
             </a:pPr>
             <a:r>
+              <a:rPr/>
               <a:t>• Каталог оверлеев: </a:t>
             </a:r>
           </a:p>
@@ -5927,6 +5967,7 @@
               </a:defRPr>
             </a:pPr>
             <a:r>
+              <a:rPr/>
               <a:t>Паки раздаются строго из %APPDATA%\PROTOKOL HUD\overlays\ по URL /overlay/&lt;pack&gt;/.</a:t>
             </a:r>
           </a:p>
@@ -5996,6 +6037,7 @@
         <p:txBody>
           <a:bodyPr wrap="square">
             <a:spAutoFit/>
+            <a:normAutofit fontScale="84000" lnSpcReduction="10000"/>
           </a:bodyPr>
           <a:lstStyle/>
           <a:p>
@@ -6007,6 +6049,7 @@
               </a:defRPr>
             </a:pPr>
             <a:r>
+              <a:rPr/>
               <a:t>2. КОНФИГУРАЦИЯ CS2 GSI</a:t>
             </a:r>
           </a:p>
@@ -6019,6 +6062,7 @@
               </a:defRPr>
             </a:pPr>
             <a:r>
+              <a:rPr/>
               <a:t>• Автопоиск каталога CS2: </a:t>
             </a:r>
           </a:p>
@@ -6031,6 +6075,7 @@
               </a:defRPr>
             </a:pPr>
             <a:r>
+              <a:rPr/>
               <a:t>Кнопка «Установить GSI cfg в CS2» в Настройках автоматически находит путь к игре на дисках C:..Z:.</a:t>
             </a:r>
           </a:p>
@@ -6043,6 +6088,7 @@
               </a:defRPr>
             </a:pPr>
             <a:r>
+              <a:rPr/>
               <a:t>• Точный путь к cfg: </a:t>
             </a:r>
           </a:p>
@@ -6055,6 +6101,7 @@
               </a:defRPr>
             </a:pPr>
             <a:r>
+              <a:rPr/>
               <a:t>Создается в &lt;Steam&gt;\...\game\csgo\cfg\gamestate_integration_protokol.cfg с URI /api/gsi.</a:t>
             </a:r>
           </a:p>
@@ -6067,6 +6114,7 @@
               </a:defRPr>
             </a:pPr>
             <a:r>
+              <a:rPr/>
               <a:t>• Авторизация auth.token: </a:t>
             </a:r>
           </a:p>
@@ -6079,6 +6127,7 @@
               </a:defRPr>
             </a:pPr>
             <a:r>
+              <a:rPr/>
               <a:t>UUID v4 токен генерируется в таблице настроек и отсекает посторонний трафик (401 Unauthorized).</a:t>
             </a:r>
           </a:p>
@@ -6091,6 +6140,7 @@
               </a:defRPr>
             </a:pPr>
             <a:r>
+              <a:rPr/>
               <a:t>• Холодный старт CS2: </a:t>
             </a:r>
           </a:p>
@@ -6103,6 +6153,7 @@
               </a:defRPr>
             </a:pPr>
             <a:r>
+              <a:rPr/>
               <a:t>CS2 считывает GSI-конфиги только при старте: если игра была открыта, требуется полный перезапуск.</a:t>
             </a:r>
           </a:p>
@@ -6172,6 +6223,7 @@
         <p:txBody>
           <a:bodyPr wrap="square">
             <a:spAutoFit/>
+            <a:normAutofit fontScale="84000" lnSpcReduction="10000"/>
           </a:bodyPr>
           <a:lstStyle/>
           <a:p>
@@ -6183,6 +6235,7 @@
               </a:defRPr>
             </a:pPr>
             <a:r>
+              <a:rPr/>
               <a:t>3. НАБЛЮДАТЕЛЬ VS POV / DEDICATED</a:t>
             </a:r>
           </a:p>
@@ -6195,6 +6248,7 @@
               </a:defRPr>
             </a:pPr>
             <a:r>
+              <a:rPr/>
               <a:t>• Клиент наблюдателя (GOTV): </a:t>
             </a:r>
           </a:p>
@@ -6207,6 +6261,7 @@
               </a:defRPr>
             </a:pPr>
             <a:r>
+              <a:rPr/>
               <a:t>ОБЯЗАТЕЛЬНО: только спектатор получает от CS2 полный дамп allplayers_* по 10 игрокам.</a:t>
             </a:r>
           </a:p>
@@ -6219,6 +6274,7 @@
               </a:defRPr>
             </a:pPr>
             <a:r>
+              <a:rPr/>
               <a:t>• Ограничение POV-клиента: </a:t>
             </a:r>
           </a:p>
@@ -6231,6 +6287,7 @@
               </a:defRPr>
             </a:pPr>
             <a:r>
+              <a:rPr/>
               <a:t>Клиент обычного игрока из античит-соображений не шлет чужие данные: оверлей и радар останутся пустыми.</a:t>
             </a:r>
           </a:p>
@@ -6243,6 +6300,7 @@
               </a:defRPr>
             </a:pPr>
             <a:r>
+              <a:rPr/>
               <a:t>• Выделенный сервер: </a:t>
             </a:r>
           </a:p>
@@ -6255,6 +6313,7 @@
               </a:defRPr>
             </a:pPr>
             <a:r>
+              <a:rPr/>
               <a:t>Прямой GSI с Dedicated Server возможен, но для локального вещания стандартом является клиент обсервера.</a:t>
             </a:r>
           </a:p>
@@ -6267,6 +6326,7 @@
               </a:defRPr>
             </a:pPr>
             <a:r>
+              <a:rPr/>
               <a:t>• Сетевой обсервер: </a:t>
             </a:r>
           </a:p>
@@ -6279,6 +6339,7 @@
               </a:defRPr>
             </a:pPr>
             <a:r>
+              <a:rPr/>
               <a:t>При отдельном ПК обсервера в cfg указывается IP эфирного ПК и открывается порт 1349 TCP в Firewall.</a:t>
             </a:r>
           </a:p>
@@ -6490,6 +6551,7 @@
               </a:defRPr>
             </a:pPr>
             <a:r>
+              <a:rPr/>
               <a:t>Настройка OBS Studio и управление HUD-паками</a:t>
             </a:r>
           </a:p>
@@ -6594,6 +6656,7 @@
         <p:txBody>
           <a:bodyPr wrap="square">
             <a:spAutoFit/>
+            <a:normAutofit fontScale="84000" lnSpcReduction="10000"/>
           </a:bodyPr>
           <a:lstStyle/>
           <a:p>
@@ -6605,6 +6668,7 @@
               </a:defRPr>
             </a:pPr>
             <a:r>
+              <a:rPr/>
               <a:t>ИНТЕГРАЦИЯ В OBS STUDIO (BROWSER SOURCE)</a:t>
             </a:r>
           </a:p>
@@ -6617,6 +6681,7 @@
               </a:defRPr>
             </a:pPr>
             <a:r>
+              <a:rPr/>
               <a:t>• Параметры Browser Source: </a:t>
             </a:r>
           </a:p>
@@ -6629,6 +6694,7 @@
               </a:defRPr>
             </a:pPr>
             <a:r>
+              <a:rPr/>
               <a:t>URL: http://127.0.0.1:1349/overlay/&lt;pack&gt;/index.html. Разрешение строго 1920×1080 @ 60 FPS, поле Custom CSS оставить пустым.</a:t>
             </a:r>
           </a:p>
@@ -6641,6 +6707,7 @@
               </a:defRPr>
             </a:pPr>
             <a:r>
+              <a:rPr/>
               <a:t>• Критический флаг: Источник видим: </a:t>
             </a:r>
           </a:p>
@@ -6653,6 +6720,7 @@
               </a:defRPr>
             </a:pPr>
             <a:r>
+              <a:rPr/>
               <a:t>СНИМИТЕ флаг: «Завершать захват, когда источник невидим». Иначе при смене сцен рвется сокет /ws и HUD заново инициализируется с задержкой.</a:t>
             </a:r>
           </a:p>
@@ -6665,6 +6733,7 @@
               </a:defRPr>
             </a:pPr>
             <a:r>
+              <a:rPr/>
               <a:t>• Критический флаг: Без перезагрузки: </a:t>
             </a:r>
           </a:p>
@@ -6677,6 +6746,7 @@
               </a:defRPr>
             </a:pPr>
             <a:r>
+              <a:rPr/>
               <a:t>СНИМИТЕ флаг: «Перезагружать браузер, когда сцена становится активной». Включите аппаратное ускорение браузера в OBS.</a:t>
             </a:r>
           </a:p>
@@ -6689,6 +6759,7 @@
               </a:defRPr>
             </a:pPr>
             <a:r>
+              <a:rPr/>
               <a:t>• Прозрачный фон и сброс кэша: </a:t>
             </a:r>
           </a:p>
@@ -6701,6 +6772,7 @@
               </a:defRPr>
             </a:pPr>
             <a:r>
+              <a:rPr/>
               <a:t>Оверлеи имеют background: transparent поверх захвата игры. При обновлении CSS/JS: Правый клик в OBS → «Обновить кэш текущей страницы».</a:t>
             </a:r>
           </a:p>
@@ -6713,6 +6785,7 @@
               </a:defRPr>
             </a:pPr>
             <a:r>
+              <a:rPr/>
               <a:t>• OBS WebSocket v5 (порт :4455): </a:t>
             </a:r>
           </a:p>
@@ -6725,6 +6798,7 @@
               </a:defRPr>
             </a:pPr>
             <a:r>
+              <a:rPr/>
               <a:t>Переключение сцен (Match, Casters, Replay) и запуск трансляции/записи напрямую из вкладки «Трансляция» PROTOKOL менеджера.</a:t>
             </a:r>
           </a:p>
@@ -6794,6 +6868,7 @@
         <p:txBody>
           <a:bodyPr wrap="square">
             <a:spAutoFit/>
+            <a:normAutofit fontScale="84000" lnSpcReduction="10000"/>
           </a:bodyPr>
           <a:lstStyle/>
           <a:p>
@@ -6805,6 +6880,7 @@
               </a:defRPr>
             </a:pPr>
             <a:r>
+              <a:rPr/>
               <a:t>УПРАВЛЕНИЕ И ИМПОРТ HUD-ПАКОВ</a:t>
             </a:r>
           </a:p>
@@ -6817,6 +6893,7 @@
               </a:defRPr>
             </a:pPr>
             <a:r>
+              <a:rPr/>
               <a:t>• Каталог раздачи в AppData: </a:t>
             </a:r>
           </a:p>
@@ -6829,6 +6906,7 @@
               </a:defRPr>
             </a:pPr>
             <a:r>
+              <a:rPr/>
               <a:t>Сервер раздает паки из %APPDATA%\PROTOKOL HUD\overlays\&lt;pack&gt;\. Старые паки OpenHUD мигрируют автоматически при старте.</a:t>
             </a:r>
           </a:p>
@@ -6841,6 +6919,7 @@
               </a:defRPr>
             </a:pPr>
             <a:r>
+              <a:rPr/>
               <a:t>• Импорт паков из ZIP через GUI: </a:t>
             </a:r>
           </a:p>
@@ -6853,6 +6932,7 @@
               </a:defRPr>
             </a:pPr>
             <a:r>
+              <a:rPr/>
               <a:t>Вкладка «HUD-паки» → поле «Импорт пака из ZIP» → указать путь и нажать «Установить». Встроена защита от Zip-Slip / Path Traversal.</a:t>
             </a:r>
           </a:p>
@@ -6865,6 +6945,7 @@
               </a:defRPr>
             </a:pPr>
             <a:r>
+              <a:rPr/>
               <a:t>• Структура автономного пака: </a:t>
             </a:r>
           </a:p>
@@ -6877,6 +6958,7 @@
               </a:defRPr>
             </a:pPr>
             <a:r>
+              <a:rPr/>
               <a:t>Минимум: index.html, hud.js, hud.css, assets/ и radars.json. Подключение общего транспорта: &lt;script src="../_core/core.js"&gt;.</a:t>
             </a:r>
           </a:p>
@@ -6889,6 +6971,7 @@
               </a:defRPr>
             </a:pPr>
             <a:r>
+              <a:rPr/>
               <a:t>• Мгновенная смена активного HUD: </a:t>
             </a:r>
           </a:p>
@@ -6901,6 +6984,7 @@
               </a:defRPr>
             </a:pPr>
             <a:r>
+              <a:rPr/>
               <a:t>Выбор стиля в приложении не требует перезапуска OBS: событие hud_activated мгновенно передается открытым оверлеям по WebSocket.</a:t>
             </a:r>
           </a:p>
@@ -6913,6 +6997,7 @@
               </a:defRPr>
             </a:pPr>
             <a:r>
+              <a:rPr/>
               <a:t>• 3 готовых турнирных стиля: </a:t>
             </a:r>
           </a:p>
@@ -6925,6 +7010,7 @@
               </a:defRPr>
             </a:pPr>
             <a:r>
+              <a:rPr/>
               <a:t>fennec-cyber (неон/скайлайн), fennec-broadcast (ТВ-таблицы/стекло) и fennec-championship (золото/оникс) полностью готовы к эфиру.</a:t>
             </a:r>
           </a:p>
@@ -7136,6 +7222,7 @@
               </a:defRPr>
             </a:pPr>
             <a:r>
+              <a:rPr/>
               <a:t>Веб-камеры игроков, регламент эфира и диагностика</a:t>
             </a:r>
           </a:p>
@@ -7240,6 +7327,7 @@
         <p:txBody>
           <a:bodyPr wrap="square">
             <a:spAutoFit/>
+            <a:normAutofit fontScale="84000" lnSpcReduction="10000"/>
           </a:bodyPr>
           <a:lstStyle/>
           <a:p>
@@ -7251,6 +7339,7 @@
               </a:defRPr>
             </a:pPr>
             <a:r>
+              <a:rPr/>
               <a:t>СИСТЕМА ДИНАМИЧЕСКОГО ФОКУСА ВЕБ-КАМЕР</a:t>
             </a:r>
           </a:p>
@@ -7263,6 +7352,7 @@
               </a:defRPr>
             </a:pPr>
             <a:r>
+              <a:rPr/>
               <a:t>• Привязка по 17-значному SteamID64: </a:t>
             </a:r>
           </a:p>
@@ -7275,6 +7365,7 @@
               </a:defRPr>
             </a:pPr>
             <a:r>
+              <a:rPr/>
               <a:t>Страница «Веб-камеры»: каждый SteamID связывается с видеопотоком. При спектаторстве в CS2 видео монтируется в карточку автоматически.</a:t>
             </a:r>
           </a:p>
@@ -7287,6 +7378,7 @@
               </a:defRPr>
             </a:pPr>
             <a:r>
+              <a:rPr/>
               <a:t>• Кэширование DOM без мерцания: </a:t>
             </a:r>
           </a:p>
@@ -7299,6 +7391,7 @@
               </a:defRPr>
             </a:pPr>
             <a:r>
+              <a:rPr/>
               <a:t>Пока спектатор наблюдает за одним игроком, тики GSI не пересоздают DOM-элемент &lt;video&gt;/&lt;iframe&gt; (cameraSlots) и не сбрасывают видеопоток.</a:t>
             </a:r>
           </a:p>
@@ -7311,6 +7404,7 @@
               </a:defRPr>
             </a:pPr>
             <a:r>
+              <a:rPr/>
               <a:t>• Поддержка VDO.Ninja и Direct Video: </a:t>
             </a:r>
           </a:p>
@@ -7323,6 +7417,7 @@
               </a:defRPr>
             </a:pPr>
             <a:r>
+              <a:rPr/>
               <a:t>Формат iframe: https://vdo.ninja/?view=...&amp;cleanoutput&amp;transparent. Параметр &amp;muted выставляется ядром принудительно для защиты от эха.</a:t>
             </a:r>
           </a:p>
@@ -7335,6 +7430,7 @@
               </a:defRPr>
             </a:pPr>
             <a:r>
+              <a:rPr/>
               <a:t>• Штатный Dual-Mode фолбэк на агента: </a:t>
             </a:r>
           </a:p>
@@ -7347,6 +7443,7 @@
               </a:defRPr>
             </a:pPr>
             <a:r>
+              <a:rPr/>
               <a:t>При отсутствии камеры отображается статический 2D-бодишот агента CS2 (CT/T). Параметр ?cam=live делает вырез прозрачным под камеру OBS.</a:t>
             </a:r>
           </a:p>
@@ -7359,6 +7456,7 @@
               </a:defRPr>
             </a:pPr>
             <a:r>
+              <a:rPr/>
               <a:t>• Встроенный предпросмотр перед матчем: </a:t>
             </a:r>
           </a:p>
@@ -7371,6 +7469,7 @@
               </a:defRPr>
             </a:pPr>
             <a:r>
+              <a:rPr/>
               <a:t>Оператор трансляции может проверить видео каждого игрока в модальном плеере менеджера до выхода в эфир.</a:t>
             </a:r>
           </a:p>
@@ -7440,6 +7539,7 @@
         <p:txBody>
           <a:bodyPr wrap="square">
             <a:spAutoFit/>
+            <a:normAutofit fontScale="84000" lnSpcReduction="10000"/>
           </a:bodyPr>
           <a:lstStyle/>
           <a:p>
@@ -7451,6 +7551,7 @@
               </a:defRPr>
             </a:pPr>
             <a:r>
+              <a:rPr/>
               <a:t>ЧЕК-ЛИСТ ОПЕРАТОРА И УСТРАНЕНИЕ НЕПОЛАДОК</a:t>
             </a:r>
           </a:p>
@@ -7463,6 +7564,7 @@
               </a:defRPr>
             </a:pPr>
             <a:r>
+              <a:rPr/>
               <a:t>• Порядок запуска (Launch Ordering): </a:t>
             </a:r>
           </a:p>
@@ -7475,6 +7577,7 @@
               </a:defRPr>
             </a:pPr>
             <a:r>
+              <a:rPr/>
               <a:t>1. Запуск PROTOKOL Manager (:1349) → 2. Запуск OBS Studio → 3. Холодный запуск CS2 (обсервер) → 4. Вход на сервер / GOTV.</a:t>
             </a:r>
           </a:p>
@@ -7487,6 +7590,7 @@
               </a:defRPr>
             </a:pPr>
             <a:r>
+              <a:rPr/>
               <a:t>• Видно только 1 игрока, радар пустой: </a:t>
             </a:r>
           </a:p>
@@ -7499,6 +7603,7 @@
               </a:defRPr>
             </a:pPr>
             <a:r>
+              <a:rPr/>
               <a:t>CS2 запущена на обычном клиентском POV-аккаунте. Перейдите в режим наблюдателя (spectator) или GOTV.</a:t>
             </a:r>
           </a:p>
@@ -7511,6 +7616,7 @@
               </a:defRPr>
             </a:pPr>
             <a:r>
+              <a:rPr/>
               <a:t>• Индикатор Live неактивен, нет данных: </a:t>
             </a:r>
           </a:p>
@@ -7523,6 +7629,7 @@
               </a:defRPr>
             </a:pPr>
             <a:r>
+              <a:rPr/>
               <a:t>CS2 не перезапускалась после создания cfg; cfg в старой csgo\cfg\; не совпадает auth.token; порт 1349 занят (netstat -ano).</a:t>
             </a:r>
           </a:p>
@@ -7535,6 +7642,7 @@
               </a:defRPr>
             </a:pPr>
             <a:r>
+              <a:rPr/>
               <a:t>• Чёрный экран оверлея в OBS Studio: </a:t>
             </a:r>
           </a:p>
@@ -7547,6 +7655,7 @@
               </a:defRPr>
             </a:pPr>
             <a:r>
+              <a:rPr/>
               <a:t>Проверьте URL: /overlay/&lt;name&gt;/index.html (overlay в ед. числе), проверьте файлы в %APPDATA%, обновите кэш Browser Source.</a:t>
             </a:r>
           </a:p>
@@ -7559,6 +7668,7 @@
               </a:defRPr>
             </a:pPr>
             <a:r>
+              <a:rPr/>
               <a:t>• Веб-камера игрока не отображается: </a:t>
             </a:r>
           </a:p>
@@ -7571,6 +7681,7 @@
               </a:defRPr>
             </a:pPr>
             <a:r>
+              <a:rPr/>
               <a:t>Проверьте SteamID (ровно 17 цифр), проверьте отсутствие логина/пароля в URL, выберите тип «iframe / VDO.Ninja» для ссылок VDO.</a:t>
             </a:r>
           </a:p>
@@ -7782,6 +7893,7 @@
               </a:defRPr>
             </a:pPr>
             <a:r>
+              <a:rPr/>
               <a:t>Преодоление ограничений устаревших HUD-решений</a:t>
             </a:r>
           </a:p>
@@ -8532,6 +8644,7 @@
               </a:defRPr>
             </a:pPr>
             <a:r>
+              <a:rPr/>
               <a:t>Скомпилированное нативное ядро</a:t>
             </a:r>
           </a:p>
@@ -8544,6 +8657,7 @@
               </a:defRPr>
             </a:pPr>
             <a:r>
+              <a:rPr/>
               <a:t>Бэкенд на Rust с Axum и асинхронным рантаймом Tokio вместо интерпретируемых серверных скриптов.</a:t>
             </a:r>
           </a:p>
@@ -8667,6 +8781,7 @@
               </a:defRPr>
             </a:pPr>
             <a:r>
+              <a:rPr/>
               <a:t>Единый настольный комплекс</a:t>
             </a:r>
           </a:p>
@@ -8679,6 +8794,7 @@
               </a:defRPr>
             </a:pPr>
             <a:r>
+              <a:rPr/>
               <a:t>Tauri v2 объединяет интерфейс оператора, прием GSI, хранилище SQLite и отдачу оверлеев в единое приложение.</a:t>
             </a:r>
           </a:p>
@@ -8802,6 +8918,7 @@
               </a:defRPr>
             </a:pPr>
             <a:r>
+              <a:rPr/>
               <a:t>Честная модульная экосистема</a:t>
             </a:r>
           </a:p>
@@ -8814,6 +8931,7 @@
               </a:defRPr>
             </a:pPr>
             <a:r>
+              <a:rPr/>
               <a:t>Централизованный интерфейс оператора для управления составами, картами, спонсорами и стилями без перезапуска игры.</a:t>
             </a:r>
           </a:p>
@@ -9025,6 +9143,7 @@
               </a:defRPr>
             </a:pPr>
             <a:r>
+              <a:rPr/>
               <a:t>Fennec Cyber: Футуристичный Sci-Fi и неон</a:t>
             </a:r>
           </a:p>
@@ -9233,6 +9352,7 @@
         <p:txBody>
           <a:bodyPr wrap="square">
             <a:spAutoFit/>
+            <a:normAutofit fontScale="63000" lnSpcReduction="10000"/>
           </a:bodyPr>
           <a:lstStyle/>
           <a:p>
@@ -9244,6 +9364,7 @@
               </a:defRPr>
             </a:pPr>
             <a:r>
+              <a:rPr/>
               <a:t>• Геометрия</a:t>
             </a:r>
           </a:p>
@@ -9256,6 +9377,7 @@
               </a:defRPr>
             </a:pPr>
             <a:r>
+              <a:rPr/>
               <a:t>Скошенные полигональные углы (clip-path: 45°), кибер-сетка и эффект динамического свечения элементов.</a:t>
             </a:r>
           </a:p>
@@ -9273,6 +9395,7 @@
               </a:defRPr>
             </a:pPr>
             <a:r>
+              <a:rPr/>
               <a:t>• Цветовая схема</a:t>
             </a:r>
           </a:p>
@@ -9285,6 +9408,7 @@
               </a:defRPr>
             </a:pPr>
             <a:r>
+              <a:rPr/>
               <a:t>Неоновый циан (#00f0ff) для спецназа (CT) и неоновый пурпур/розовый (#ff007f) для террористов (T).</a:t>
             </a:r>
           </a:p>
@@ -9302,6 +9426,7 @@
               </a:defRPr>
             </a:pPr>
             <a:r>
+              <a:rPr/>
               <a:t>• Окно веб-камеры</a:t>
             </a:r>
           </a:p>
@@ -9314,6 +9439,7 @@
               </a:defRPr>
             </a:pPr>
             <a:r>
+              <a:rPr/>
               <a:t>Встроенная скошенная 16:9 окантовка с бейджем «LIVE CAM». При отсутствии камеры отображается статический агент.</a:t>
             </a:r>
           </a:p>
@@ -9331,6 +9457,7 @@
               </a:defRPr>
             </a:pPr>
             <a:r>
+              <a:rPr/>
               <a:t>• Векторный радар</a:t>
             </a:r>
           </a:p>
@@ -9343,6 +9470,7 @@
               </a:defRPr>
             </a:pPr>
             <a:r>
+              <a:rPr/>
               <a:t>Чистые неоновые контуры карты CS2 без громоздкого черного фонового квадрата (альфа-прозрачность).</a:t>
             </a:r>
           </a:p>
@@ -9360,6 +9488,7 @@
               </a:defRPr>
             </a:pPr>
             <a:r>
+              <a:rPr/>
               <a:t>• Назначение</a:t>
             </a:r>
           </a:p>
@@ -9372,6 +9501,7 @@
               </a:defRPr>
             </a:pPr>
             <a:r>
+              <a:rPr/>
               <a:t>Молодежные лиги, шоу-матчи, стримерские турниры, вечерние киберспортивные трансляции.</a:t>
             </a:r>
           </a:p>
@@ -9583,6 +9713,7 @@
               </a:defRPr>
             </a:pPr>
             <a:r>
+              <a:rPr/>
               <a:t>Fennec Broadcast: Чистая студийная эстетика</a:t>
             </a:r>
           </a:p>
@@ -9791,6 +9922,7 @@
         <p:txBody>
           <a:bodyPr wrap="square">
             <a:spAutoFit/>
+            <a:normAutofit fontScale="68000" lnSpcReduction="10000"/>
           </a:bodyPr>
           <a:lstStyle/>
           <a:p>
@@ -9802,6 +9934,7 @@
               </a:defRPr>
             </a:pPr>
             <a:r>
+              <a:rPr/>
               <a:t>• Эргономика ТВ</a:t>
             </a:r>
           </a:p>
@@ -9814,6 +9947,7 @@
               </a:defRPr>
             </a:pPr>
             <a:r>
+              <a:rPr/>
               <a:t>Аккуратные скругленные углы (10px), сбалансированное центрирование фокус-панели и окна веб-камеры.</a:t>
             </a:r>
           </a:p>
@@ -9831,6 +9965,7 @@
               </a:defRPr>
             </a:pPr>
             <a:r>
+              <a:rPr/>
               <a:t>• Эффект матового стекла</a:t>
             </a:r>
           </a:p>
@@ -9843,6 +9978,7 @@
               </a:defRPr>
             </a:pPr>
             <a:r>
+              <a:rPr/>
               <a:t>Использование backdrop-filter: blur(16px) для мягкой интеграции поверх любой карты и игровых спецэффектов.</a:t>
             </a:r>
           </a:p>
@@ -9860,6 +9996,7 @@
               </a:defRPr>
             </a:pPr>
             <a:r>
+              <a:rPr/>
               <a:t>• Цветовая палитра</a:t>
             </a:r>
           </a:p>
@@ -9872,6 +10009,7 @@
               </a:defRPr>
             </a:pPr>
             <a:r>
+              <a:rPr/>
               <a:t>Глубокий кобальтовый синий (#1a56db) и благородный янтарный оранжевый (#f59e0b).</a:t>
             </a:r>
           </a:p>
@@ -9889,6 +10027,7 @@
               </a:defRPr>
             </a:pPr>
             <a:r>
+              <a:rPr/>
               <a:t>• Типографика</a:t>
             </a:r>
           </a:p>
@@ -9901,6 +10040,7 @@
               </a:defRPr>
             </a:pPr>
             <a:r>
+              <a:rPr/>
               <a:t>Крупные, четко считываемые цифры здоровья, патронов и статус саппорт-утилит команд.</a:t>
             </a:r>
           </a:p>
@@ -9918,6 +10058,7 @@
               </a:defRPr>
             </a:pPr>
             <a:r>
+              <a:rPr/>
               <a:t>• Назначение</a:t>
             </a:r>
           </a:p>
@@ -9930,6 +10071,7 @@
               </a:defRPr>
             </a:pPr>
             <a:r>
+              <a:rPr/>
               <a:t>Студийные трансляции, профессиональные лиги, форматы уровня PGL / BLAST.</a:t>
             </a:r>
           </a:p>
@@ -10141,6 +10283,7 @@
               </a:defRPr>
             </a:pPr>
             <a:r>
+              <a:rPr/>
               <a:t>Fennec Championship: Оникс и королевское золото</a:t>
             </a:r>
           </a:p>
@@ -10349,6 +10492,7 @@
         <p:txBody>
           <a:bodyPr wrap="square">
             <a:spAutoFit/>
+            <a:normAutofit fontScale="74000" lnSpcReduction="10000"/>
           </a:bodyPr>
           <a:lstStyle/>
           <a:p>
@@ -10360,6 +10504,7 @@
               </a:defRPr>
             </a:pPr>
             <a:r>
+              <a:rPr/>
               <a:t>• Премиальный визуал</a:t>
             </a:r>
           </a:p>
@@ -10372,6 +10517,7 @@
               </a:defRPr>
             </a:pPr>
             <a:r>
+              <a:rPr/>
               <a:t>Глубокий оникс (#0d0f14), металлический графит и градиентное королевское золото (#ffd700).</a:t>
             </a:r>
           </a:p>
@@ -10389,6 +10535,7 @@
               </a:defRPr>
             </a:pPr>
             <a:r>
+              <a:rPr/>
               <a:t>• Статус решающего матча</a:t>
             </a:r>
           </a:p>
@@ -10401,6 +10548,7 @@
               </a:defRPr>
             </a:pPr>
             <a:r>
+              <a:rPr/>
               <a:t>Золотой шеврон первенства, акцентные полосы активности раунда и победные фреймы.</a:t>
             </a:r>
           </a:p>
@@ -10418,6 +10566,7 @@
               </a:defRPr>
             </a:pPr>
             <a:r>
+              <a:rPr/>
               <a:t>• Рамка веб-камеры</a:t>
             </a:r>
           </a:p>
@@ -10430,6 +10579,7 @@
               </a:defRPr>
             </a:pPr>
             <a:r>
+              <a:rPr/>
               <a:t>Двойная металлическая окантовка 2px с золотым шильдиком никнейма и KDA активного игрока.</a:t>
             </a:r>
           </a:p>
@@ -10447,6 +10597,7 @@
               </a:defRPr>
             </a:pPr>
             <a:r>
+              <a:rPr/>
               <a:t>• Коррекция типографики</a:t>
             </a:r>
           </a:p>
@@ -10459,6 +10610,7 @@
               </a:defRPr>
             </a:pPr>
             <a:r>
+              <a:rPr/>
               <a:t>Верифицирована посадка составных никнеймов без переносов слов на всех разрешениях.</a:t>
             </a:r>
           </a:p>
@@ -10476,6 +10628,7 @@
               </a:defRPr>
             </a:pPr>
             <a:r>
+              <a:rPr/>
               <a:t>• Назначение</a:t>
             </a:r>
           </a:p>
@@ -10488,6 +10641,7 @@
               </a:defRPr>
             </a:pPr>
             <a:r>
+              <a:rPr/>
               <a:t>Финальные стадии, арена-трансляции, турнирные серии и шоу-матчи.</a:t>
             </a:r>
           </a:p>
@@ -10699,6 +10853,7 @@
               </a:defRPr>
             </a:pPr>
             <a:r>
+              <a:rPr/>
               <a:t>Двухрежимная система отображения веб-камер</a:t>
             </a:r>
           </a:p>
@@ -10907,6 +11062,7 @@
         <p:txBody>
           <a:bodyPr wrap="square">
             <a:spAutoFit/>
+            <a:normAutofit fontScale="65000" lnSpcReduction="10000"/>
           </a:bodyPr>
           <a:lstStyle/>
           <a:p>
@@ -10918,6 +11074,7 @@
               </a:defRPr>
             </a:pPr>
             <a:r>
+              <a:rPr/>
               <a:t>• Режим 1: Offline / Без стримера</a:t>
             </a:r>
           </a:p>
@@ -10930,6 +11087,7 @@
               </a:defRPr>
             </a:pPr>
             <a:r>
+              <a:rPr/>
               <a:t>Если у игрока нет физической камеры, в 16:9 окне отображается высококачественный 3D-рендер бодишота активного агента CS2 с градиентным угасанием.</a:t>
             </a:r>
           </a:p>
@@ -10947,6 +11105,7 @@
               </a:defRPr>
             </a:pPr>
             <a:r>
+              <a:rPr/>
               <a:t>• Режим 2: Live Cam (?cam=live)</a:t>
             </a:r>
           </a:p>
@@ -10959,6 +11118,7 @@
               </a:defRPr>
             </a:pPr>
             <a:r>
+              <a:rPr/>
               <a:t>При включении камеры бодишот скрывается, а окно становится прозрачным (100%), обрамляясь фирменной рамкой выбранного стиля оверлея.</a:t>
             </a:r>
           </a:p>
@@ -10976,6 +11136,7 @@
               </a:defRPr>
             </a:pPr>
             <a:r>
+              <a:rPr/>
               <a:t>• Поддержка источников</a:t>
             </a:r>
           </a:p>
@@ -10988,6 +11149,7 @@
               </a:defRPr>
             </a:pPr>
             <a:r>
+              <a:rPr/>
               <a:t>Прямые потоки Direct Video (HLS, WebM, MP4) либо встраиваемые iframe-ссылки VDO.Ninja с автоматическим глушением звука (muted).</a:t>
             </a:r>
           </a:p>
@@ -11005,6 +11167,7 @@
               </a:defRPr>
             </a:pPr>
             <a:r>
+              <a:rPr/>
               <a:t>• Тестирование из GUI</a:t>
             </a:r>
           </a:p>
@@ -11017,6 +11180,7 @@
               </a:defRPr>
             </a:pPr>
             <a:r>
+              <a:rPr/>
               <a:t>Оператор может проверить статус потока каждого игрока в один клик прямо из таблицы управления камерами.</a:t>
             </a:r>
           </a:p>
@@ -11228,6 +11392,7 @@
               </a:defRPr>
             </a:pPr>
             <a:r>
+              <a:rPr/>
               <a:t>Централизованный нативный пульт управления трансляцией</a:t>
             </a:r>
           </a:p>
@@ -11436,6 +11601,7 @@
         <p:txBody>
           <a:bodyPr wrap="square">
             <a:spAutoFit/>
+            <a:normAutofit fontScale="71000" lnSpcReduction="10000"/>
           </a:bodyPr>
           <a:lstStyle/>
           <a:p>
@@ -11447,6 +11613,7 @@
               </a:defRPr>
             </a:pPr>
             <a:r>
+              <a:rPr/>
               <a:t>1. Автоконфигурация CS2 GSI</a:t>
             </a:r>
           </a:p>
@@ -11459,6 +11626,7 @@
               </a:defRPr>
             </a:pPr>
             <a:r>
+              <a:rPr/>
               <a:t>Менеджер самостоятельно находит директорию игры в реестре Windows и генерирует конфигурационный файл gamestate_integration_protokol.cfg.</a:t>
             </a:r>
           </a:p>
@@ -11476,6 +11644,7 @@
               </a:defRPr>
             </a:pPr>
             <a:r>
+              <a:rPr/>
               <a:t>2. Выбор активного стиля</a:t>
             </a:r>
           </a:p>
@@ -11488,6 +11657,7 @@
               </a:defRPr>
             </a:pPr>
             <a:r>
+              <a:rPr/>
               <a:t>Переключение между Cyber, Broadcast и Championship в один клик. Возможность тонкой настройки отображения радара и утилит.</a:t>
             </a:r>
           </a:p>
@@ -11505,6 +11675,7 @@
               </a:defRPr>
             </a:pPr>
             <a:r>
+              <a:rPr/>
               <a:t>3. Экспорт в OBS Studio / vMix</a:t>
             </a:r>
           </a:p>
@@ -11517,6 +11688,7 @@
               </a:defRPr>
             </a:pPr>
             <a:r>
+              <a:rPr/>
               <a:t>Кнопка быстрого копирования Browser Source URL (1080p60) исключает ошибки ручного набора адресов режиссером эфира.</a:t>
             </a:r>
           </a:p>
@@ -11534,6 +11706,7 @@
               </a:defRPr>
             </a:pPr>
             <a:r>
+              <a:rPr/>
               <a:t>4. Управление ростерами и спонсорами</a:t>
             </a:r>
           </a:p>
@@ -11546,6 +11719,7 @@
               </a:defRPr>
             </a:pPr>
             <a:r>
+              <a:rPr/>
               <a:t>Редактирование названий команд, логотипов, спонсорских плашек и связок SteamID игроков в локальной базе SQLite.</a:t>
             </a:r>
           </a:p>
@@ -11757,6 +11931,7 @@
               </a:defRPr>
             </a:pPr>
             <a:r>
+              <a:rPr/>
               <a:t>Архитектура сквозного конвейера данных (Data Flow)</a:t>
             </a:r>
           </a:p>
@@ -11872,6 +12047,7 @@
               </a:defRPr>
             </a:pPr>
             <a:r>
+              <a:rPr/>
               <a:t>1. ПРИЕМ ДАННЫХ (GSI)</a:t>
             </a:r>
           </a:p>
@@ -11884,6 +12060,7 @@
               </a:defRPr>
             </a:pPr>
             <a:r>
+              <a:rPr/>
               <a:t>• Порт :1349 (HTTP Axum 0.7)</a:t>
             </a:r>
           </a:p>
@@ -11896,6 +12073,7 @@
               </a:defRPr>
             </a:pPr>
             <a:r>
+              <a:rPr/>
               <a:t>• Прием JSON-пейлоадов от движка CS2 по спецификации GSI.</a:t>
             </a:r>
           </a:p>
@@ -11908,6 +12086,7 @@
               </a:defRPr>
             </a:pPr>
             <a:r>
+              <a:rPr/>
               <a:t>• Совместимый порт-мост :31982 с проверкой токена авторизации.</a:t>
             </a:r>
           </a:p>
@@ -11920,6 +12099,7 @@
               </a:defRPr>
             </a:pPr>
             <a:r>
+              <a:rPr/>
               <a:t>• Парсинг SteamID наблюдаемого игрока с автоматическим фолбэком.</a:t>
             </a:r>
           </a:p>
@@ -11932,6 +12112,7 @@
               </a:defRPr>
             </a:pPr>
             <a:r>
+              <a:rPr/>
               <a:t>• Трекинг фрагов раунда (round_kills) для индикации на карточке.</a:t>
             </a:r>
           </a:p>
@@ -12012,6 +12193,7 @@
               </a:defRPr>
             </a:pPr>
             <a:r>
+              <a:rPr/>
               <a:t>2. ЯДРО И БАЗА ДАННЫХ</a:t>
             </a:r>
           </a:p>
@@ -12024,6 +12206,7 @@
               </a:defRPr>
             </a:pPr>
             <a:r>
+              <a:rPr/>
               <a:t>• In-Memory State (Tokio)</a:t>
             </a:r>
           </a:p>
@@ -12036,6 +12219,7 @@
               </a:defRPr>
             </a:pPr>
             <a:r>
+              <a:rPr/>
               <a:t>• Атомарное обновление структуры MatchSnap в асинхронном рантайме.</a:t>
             </a:r>
           </a:p>
@@ -12048,6 +12232,7 @@
               </a:defRPr>
             </a:pPr>
             <a:r>
+              <a:rPr/>
               <a:t>• База SQLite в режиме WAL (Write-Ahead Logging) для персистентности сессий.</a:t>
             </a:r>
           </a:p>
@@ -12060,6 +12245,7 @@
               </a:defRPr>
             </a:pPr>
             <a:r>
+              <a:rPr/>
               <a:t>• Асинхронные задачи Tokio для записи истории без блокировки сетевого цикла.</a:t>
             </a:r>
           </a:p>
@@ -12072,6 +12258,7 @@
               </a:defRPr>
             </a:pPr>
             <a:r>
+              <a:rPr/>
               <a:t>• Компактный нативный бинарник без тяжелого виртуального окружения.</a:t>
             </a:r>
           </a:p>
@@ -12152,6 +12339,7 @@
               </a:defRPr>
             </a:pPr>
             <a:r>
+              <a:rPr/>
               <a:t>3. РЕНДЕР И РАДАР (OBS)</a:t>
             </a:r>
           </a:p>
@@ -12164,6 +12352,7 @@
               </a:defRPr>
             </a:pPr>
             <a:r>
+              <a:rPr/>
               <a:t>• WebSocket Broadcast (Realtime)</a:t>
             </a:r>
           </a:p>
@@ -12176,6 +12365,7 @@
               </a:defRPr>
             </a:pPr>
             <a:r>
+              <a:rPr/>
               <a:t>• Событийная доставка обновлений состояния матча в оверлеи OBS Studio.</a:t>
             </a:r>
           </a:p>
@@ -12188,6 +12378,7 @@
               </a:defRPr>
             </a:pPr>
             <a:r>
+              <a:rPr/>
               <a:t>• Векторный радар CS2 (18 карт, 78 конфигураций уровней).</a:t>
             </a:r>
           </a:p>
@@ -12200,6 +12391,7 @@
               </a:defRPr>
             </a:pPr>
             <a:r>
+              <a:rPr/>
               <a:t>• Прозрачный альфа-канал без черного фона с контурным свечением.</a:t>
             </a:r>
           </a:p>
@@ -12212,6 +12404,7 @@
               </a:defRPr>
             </a:pPr>
             <a:r>
+              <a:rPr/>
               <a:t>• Точный перевод мировых координат Valve Source Engine без инверсии масштаба.</a:t>
             </a:r>
           </a:p>
@@ -12423,6 +12616,7 @@
               </a:defRPr>
             </a:pPr>
             <a:r>
+              <a:rPr/>
               <a:t>Честный статус готовности релизных компонентов</a:t>
             </a:r>
           </a:p>
@@ -12527,6 +12721,7 @@
         <p:txBody>
           <a:bodyPr wrap="square">
             <a:spAutoFit/>
+            <a:normAutofit fontScale="89000" lnSpcReduction="10000"/>
           </a:bodyPr>
           <a:lstStyle/>
           <a:p>
@@ -12538,6 +12733,7 @@
               </a:defRPr>
             </a:pPr>
             <a:r>
+              <a:rPr/>
               <a:t>ПОДТВЕРЖДЕНО ТЕСТАМИ (VERIFIED)</a:t>
             </a:r>
           </a:p>
@@ -12550,6 +12746,7 @@
               </a:defRPr>
             </a:pPr>
             <a:r>
+              <a:rPr/>
               <a:t>✓ E2E тесты веб-камер 3 HUD: </a:t>
             </a:r>
           </a:p>
@@ -12562,6 +12759,7 @@
               </a:defRPr>
             </a:pPr>
             <a:r>
+              <a:rPr/>
               <a:t>Успешно декодируются видеокадры, muted playback, сохранение DOM при пакетах GSI, переключение фокуса между игроками.</a:t>
             </a:r>
           </a:p>
@@ -12574,6 +12772,7 @@
               </a:defRPr>
             </a:pPr>
             <a:r>
+              <a:rPr/>
               <a:t>✓ Геометрия оверлеев: </a:t>
             </a:r>
           </a:p>
@@ -12586,6 +12785,7 @@
               </a:defRPr>
             </a:pPr>
             <a:r>
+              <a:rPr/>
               <a:t>Проверено на разрешениях 1280×720, 1920×1080 и 2560×1440. Отсутствуют наложения блоков и выходы за границы экрана.</a:t>
             </a:r>
           </a:p>
@@ -12598,6 +12798,7 @@
               </a:defRPr>
             </a:pPr>
             <a:r>
+              <a:rPr/>
               <a:t>✓ Типографика ростеров: </a:t>
             </a:r>
           </a:p>
@@ -12610,6 +12811,7 @@
               </a:defRPr>
             </a:pPr>
             <a:r>
+              <a:rPr/>
               <a:t>Математически подтверждена однострочная посадка длинных никнеймов игроков через Range.getClientRects.</a:t>
             </a:r>
           </a:p>
@@ -12622,6 +12824,7 @@
               </a:defRPr>
             </a:pPr>
             <a:r>
+              <a:rPr/>
               <a:t>✓ Бэкенд-инженерия: </a:t>
             </a:r>
           </a:p>
@@ -12634,6 +12837,7 @@
               </a:defRPr>
             </a:pPr>
             <a:r>
+              <a:rPr/>
               <a:t>33 E2E теста бэкенда пройдены успешно; 36 модульных тестов библиотеки и 5 интеграционных тестов camera_storage выполнены без ошибок.</a:t>
             </a:r>
           </a:p>
@@ -12646,6 +12850,7 @@
               </a:defRPr>
             </a:pPr>
             <a:r>
+              <a:rPr/>
               <a:t>✓ Пакет Linux DEB: </a:t>
             </a:r>
           </a:p>
@@ -12658,6 +12863,7 @@
               </a:defRPr>
             </a:pPr>
             <a:r>
+              <a:rPr/>
               <a:t>Tauri/WebKit CRUD и превью полностью валидированы в среде Ubuntu Noble.</a:t>
             </a:r>
           </a:p>
@@ -12727,6 +12933,7 @@
         <p:txBody>
           <a:bodyPr wrap="square">
             <a:spAutoFit/>
+            <a:normAutofit fontScale="89000" lnSpcReduction="10000"/>
           </a:bodyPr>
           <a:lstStyle/>
           <a:p>
@@ -12738,6 +12945,7 @@
               </a:defRPr>
             </a:pPr>
             <a:r>
+              <a:rPr/>
               <a:t>ГРАНИЦЫ ВАЛИДАЦИИ И ОГРАНИЧЕНИЯ (HONEST DISCLOSURE)</a:t>
             </a:r>
           </a:p>
@@ -12750,6 +12958,7 @@
               </a:defRPr>
             </a:pPr>
             <a:r>
+              <a:rPr/>
               <a:t>• Windows Runtime верификация: </a:t>
             </a:r>
           </a:p>
@@ -12762,6 +12971,7 @@
               </a:defRPr>
             </a:pPr>
             <a:r>
+              <a:rPr/>
               <a:t>Сборка protokol-hud-manager.exe (18.8 МБ) и NSIS установщика (114 МБ) успешно скомпилирована. Заголовки PE и контрольные суммы SHA-256 проверены. Финальное подтверждение нативного Windows GUI остается открытым (signoff pending) до ручной приемки в среде с системным WebView2.</a:t>
             </a:r>
           </a:p>
@@ -12774,6 +12984,7 @@
               </a:defRPr>
             </a:pPr>
             <a:r>
+              <a:rPr/>
               <a:t>• Синтетические видеофид-фикстуры: </a:t>
             </a:r>
           </a:p>
@@ -12786,6 +12997,7 @@
               </a:defRPr>
             </a:pPr>
             <a:r>
+              <a:rPr/>
               <a:t>Текущие скриншоты оверлеев используют сгенерированные тестовые таблицы (SMPTE таймкод), а не живые потоки VDO.Ninja реального турнира. Сквозная турнирная сессия CS2 в боевых условиях пока не подтверждена.</a:t>
             </a:r>
           </a:p>
@@ -12798,6 +13010,7 @@
               </a:defRPr>
             </a:pPr>
             <a:r>
+              <a:rPr/>
               <a:t>• Отсутствие невалидированных бенчмарков: </a:t>
             </a:r>
           </a:p>
@@ -12810,6 +13023,7 @@
               </a:defRPr>
             </a:pPr>
             <a:r>
+              <a:rPr/>
               <a:t>В релизных материалах исключены неподтвержденные бенчмарки RAM и задержек, а также громкие маркетинговые статусы. Текущая версия приложения — 0.1.0.</a:t>
             </a:r>
           </a:p>

</xml_diff>

<commit_message>
Fix PowerPoint-open failure: duplicate spAutoFit+normAutofit in bodyPr (schema violation); keep single normAutofit, regenerate all 13 slides
</commit_message>
<xml_diff>
--- a/docs/presentation/protokol-presentation.pptx
+++ b/docs/presentation/protokol-presentation.pptx
@@ -5850,7 +5850,6 @@
         </p:spPr>
         <p:txBody>
           <a:bodyPr wrap="square">
-            <a:spAutoFit/>
             <a:normAutofit fontScale="89000" lnSpcReduction="10000"/>
           </a:bodyPr>
           <a:lstStyle/>
@@ -6036,7 +6035,6 @@
         </p:spPr>
         <p:txBody>
           <a:bodyPr wrap="square">
-            <a:spAutoFit/>
             <a:normAutofit fontScale="84000" lnSpcReduction="10000"/>
           </a:bodyPr>
           <a:lstStyle/>
@@ -6222,7 +6220,6 @@
         </p:spPr>
         <p:txBody>
           <a:bodyPr wrap="square">
-            <a:spAutoFit/>
             <a:normAutofit fontScale="84000" lnSpcReduction="10000"/>
           </a:bodyPr>
           <a:lstStyle/>
@@ -6655,7 +6652,6 @@
         </p:spPr>
         <p:txBody>
           <a:bodyPr wrap="square">
-            <a:spAutoFit/>
             <a:normAutofit fontScale="84000" lnSpcReduction="10000"/>
           </a:bodyPr>
           <a:lstStyle/>
@@ -6867,7 +6863,6 @@
         </p:spPr>
         <p:txBody>
           <a:bodyPr wrap="square">
-            <a:spAutoFit/>
             <a:normAutofit fontScale="84000" lnSpcReduction="10000"/>
           </a:bodyPr>
           <a:lstStyle/>
@@ -7326,7 +7321,6 @@
         </p:spPr>
         <p:txBody>
           <a:bodyPr wrap="square">
-            <a:spAutoFit/>
             <a:normAutofit fontScale="84000" lnSpcReduction="10000"/>
           </a:bodyPr>
           <a:lstStyle/>
@@ -7538,7 +7532,6 @@
         </p:spPr>
         <p:txBody>
           <a:bodyPr wrap="square">
-            <a:spAutoFit/>
             <a:normAutofit fontScale="84000" lnSpcReduction="10000"/>
           </a:bodyPr>
           <a:lstStyle/>
@@ -9351,7 +9344,6 @@
         </p:spPr>
         <p:txBody>
           <a:bodyPr wrap="square">
-            <a:spAutoFit/>
             <a:normAutofit fontScale="63000" lnSpcReduction="10000"/>
           </a:bodyPr>
           <a:lstStyle/>
@@ -9921,7 +9913,6 @@
         </p:spPr>
         <p:txBody>
           <a:bodyPr wrap="square">
-            <a:spAutoFit/>
             <a:normAutofit fontScale="68000" lnSpcReduction="10000"/>
           </a:bodyPr>
           <a:lstStyle/>
@@ -10491,7 +10482,6 @@
         </p:spPr>
         <p:txBody>
           <a:bodyPr wrap="square">
-            <a:spAutoFit/>
             <a:normAutofit fontScale="74000" lnSpcReduction="10000"/>
           </a:bodyPr>
           <a:lstStyle/>
@@ -11061,7 +11051,6 @@
         </p:spPr>
         <p:txBody>
           <a:bodyPr wrap="square">
-            <a:spAutoFit/>
             <a:normAutofit fontScale="65000" lnSpcReduction="10000"/>
           </a:bodyPr>
           <a:lstStyle/>
@@ -11600,7 +11589,6 @@
         </p:spPr>
         <p:txBody>
           <a:bodyPr wrap="square">
-            <a:spAutoFit/>
             <a:normAutofit fontScale="71000" lnSpcReduction="10000"/>
           </a:bodyPr>
           <a:lstStyle/>
@@ -12720,7 +12708,6 @@
         </p:spPr>
         <p:txBody>
           <a:bodyPr wrap="square">
-            <a:spAutoFit/>
             <a:normAutofit fontScale="89000" lnSpcReduction="10000"/>
           </a:bodyPr>
           <a:lstStyle/>
@@ -12932,7 +12919,6 @@
         </p:spPr>
         <p:txBody>
           <a:bodyPr wrap="square">
-            <a:spAutoFit/>
             <a:normAutofit fontScale="89000" lnSpcReduction="10000"/>
           </a:bodyPr>
           <a:lstStyle/>

</xml_diff>

<commit_message>
docs: update executive presentation with Tier-1 Major verified HUD slides
</commit_message>
<xml_diff>
--- a/docs/presentation/protokol-presentation.pptx
+++ b/docs/presentation/protokol-presentation.pptx
@@ -9224,7 +9224,7 @@
       </p:sp>
       <p:pic>
         <p:nvPicPr>
-          <p:cNvPr id="6" name="Picture 5" descr="fennec-cyber-agent-transparent.png"/>
+          <p:cNvPr id="6" name="Picture 5" descr="fennec-cyber-verified-major-standards.png"/>
           <p:cNvPicPr>
             <a:picLocks noChangeAspect="1"/>
           </p:cNvPicPr>
@@ -9793,7 +9793,7 @@
       </p:sp>
       <p:pic>
         <p:nvPicPr>
-          <p:cNvPr id="6" name="Picture 5" descr="fennec-broadcast-agent-transparent.png"/>
+          <p:cNvPr id="6" name="Picture 5" descr="fennec-broadcast-verified-major-standards.png"/>
           <p:cNvPicPr>
             <a:picLocks noChangeAspect="1"/>
           </p:cNvPicPr>
@@ -10362,7 +10362,7 @@
       </p:sp>
       <p:pic>
         <p:nvPicPr>
-          <p:cNvPr id="6" name="Picture 5" descr="fennec-championship-agent-transparent.png"/>
+          <p:cNvPr id="6" name="Picture 5" descr="fennec-championship-verified-major-standards.png"/>
           <p:cNvPicPr>
             <a:picLocks noChangeAspect="1"/>
           </p:cNvPicPr>

</xml_diff>

<commit_message>
style: borderless clean Major broadcast presentation for webcams and agent fallbacks
</commit_message>
<xml_diff>
--- a/docs/presentation/protokol-presentation.pptx
+++ b/docs/presentation/protokol-presentation.pptx
@@ -9224,7 +9224,7 @@
       </p:sp>
       <p:pic>
         <p:nvPicPr>
-          <p:cNvPr id="6" name="Picture 5" descr="fennec-cyber-verified-major-standards.png"/>
+          <p:cNvPr id="6" name="Picture 5" descr="fennec-cyber-clean-agent-major.png"/>
           <p:cNvPicPr>
             <a:picLocks noChangeAspect="1"/>
           </p:cNvPicPr>
@@ -9793,7 +9793,7 @@
       </p:sp>
       <p:pic>
         <p:nvPicPr>
-          <p:cNvPr id="6" name="Picture 5" descr="fennec-broadcast-verified-major-standards.png"/>
+          <p:cNvPr id="6" name="Picture 5" descr="fennec-broadcast-clean-agent-major.png"/>
           <p:cNvPicPr>
             <a:picLocks noChangeAspect="1"/>
           </p:cNvPicPr>
@@ -10362,7 +10362,7 @@
       </p:sp>
       <p:pic>
         <p:nvPicPr>
-          <p:cNvPr id="6" name="Picture 5" descr="fennec-championship-verified-major-standards.png"/>
+          <p:cNvPr id="6" name="Picture 5" descr="fennec-championship-clean-agent-major.png"/>
           <p:cNvPicPr>
             <a:picLocks noChangeAspect="1"/>
           </p:cNvPicPr>

</xml_diff>